<commit_message>
Sir Gideon Ofnir the All-Knowing | Fix minor mistakes in project management chapter; Change format of project organization diagram image; Nearly done with sensor choice chapter; Add images, diagrams and physical sketches to visualize
</commit_message>
<xml_diff>
--- a/Diplomarbeit/doc/Schaar/Projektorganisationsdiagramm_DigiKicker.pptx
+++ b/Diplomarbeit/doc/Schaar/Projektorganisationsdiagramm_DigiKicker.pptx
@@ -2,7 +2,7 @@
 <file path=ppt/presentation.xml><?xml version="1.0" encoding="utf-8"?>
 <p:presentation xmlns:a="http://schemas.openxmlformats.org/drawingml/2006/main" xmlns:r="http://schemas.openxmlformats.org/officeDocument/2006/relationships" xmlns:p="http://schemas.openxmlformats.org/presentationml/2006/main" saveSubsetFonts="1">
   <p:sldMasterIdLst>
-    <p:sldMasterId id="2147483648" r:id="rId1"/>
+    <p:sldMasterId id="2147483672" r:id="rId1"/>
   </p:sldMasterIdLst>
   <p:notesMasterIdLst>
     <p:notesMasterId r:id="rId3"/>
@@ -10,13 +10,13 @@
   <p:sldIdLst>
     <p:sldId id="257" r:id="rId2"/>
   </p:sldIdLst>
-  <p:sldSz cx="12192000" cy="6858000"/>
+  <p:sldSz cx="7862888" cy="6832600"/>
   <p:notesSz cx="6858000" cy="9144000"/>
   <p:defaultTextStyle>
     <a:defPPr>
-      <a:defRPr lang="de-DE"/>
+      <a:defRPr lang="en-US"/>
     </a:defPPr>
-    <a:lvl1pPr marL="0" algn="l" defTabSz="914400" rtl="0" eaLnBrk="1" latinLnBrk="0" hangingPunct="1">
+    <a:lvl1pPr marL="0" algn="l" defTabSz="457200" rtl="0" eaLnBrk="1" latinLnBrk="0" hangingPunct="1">
       <a:defRPr sz="1800" kern="1200">
         <a:solidFill>
           <a:schemeClr val="tx1"/>
@@ -26,7 +26,7 @@
         <a:cs typeface="+mn-cs"/>
       </a:defRPr>
     </a:lvl1pPr>
-    <a:lvl2pPr marL="457200" algn="l" defTabSz="914400" rtl="0" eaLnBrk="1" latinLnBrk="0" hangingPunct="1">
+    <a:lvl2pPr marL="457200" algn="l" defTabSz="457200" rtl="0" eaLnBrk="1" latinLnBrk="0" hangingPunct="1">
       <a:defRPr sz="1800" kern="1200">
         <a:solidFill>
           <a:schemeClr val="tx1"/>
@@ -36,7 +36,7 @@
         <a:cs typeface="+mn-cs"/>
       </a:defRPr>
     </a:lvl2pPr>
-    <a:lvl3pPr marL="914400" algn="l" defTabSz="914400" rtl="0" eaLnBrk="1" latinLnBrk="0" hangingPunct="1">
+    <a:lvl3pPr marL="914400" algn="l" defTabSz="457200" rtl="0" eaLnBrk="1" latinLnBrk="0" hangingPunct="1">
       <a:defRPr sz="1800" kern="1200">
         <a:solidFill>
           <a:schemeClr val="tx1"/>
@@ -46,7 +46,7 @@
         <a:cs typeface="+mn-cs"/>
       </a:defRPr>
     </a:lvl3pPr>
-    <a:lvl4pPr marL="1371600" algn="l" defTabSz="914400" rtl="0" eaLnBrk="1" latinLnBrk="0" hangingPunct="1">
+    <a:lvl4pPr marL="1371600" algn="l" defTabSz="457200" rtl="0" eaLnBrk="1" latinLnBrk="0" hangingPunct="1">
       <a:defRPr sz="1800" kern="1200">
         <a:solidFill>
           <a:schemeClr val="tx1"/>
@@ -56,7 +56,7 @@
         <a:cs typeface="+mn-cs"/>
       </a:defRPr>
     </a:lvl4pPr>
-    <a:lvl5pPr marL="1828800" algn="l" defTabSz="914400" rtl="0" eaLnBrk="1" latinLnBrk="0" hangingPunct="1">
+    <a:lvl5pPr marL="1828800" algn="l" defTabSz="457200" rtl="0" eaLnBrk="1" latinLnBrk="0" hangingPunct="1">
       <a:defRPr sz="1800" kern="1200">
         <a:solidFill>
           <a:schemeClr val="tx1"/>
@@ -66,7 +66,7 @@
         <a:cs typeface="+mn-cs"/>
       </a:defRPr>
     </a:lvl5pPr>
-    <a:lvl6pPr marL="2286000" algn="l" defTabSz="914400" rtl="0" eaLnBrk="1" latinLnBrk="0" hangingPunct="1">
+    <a:lvl6pPr marL="2286000" algn="l" defTabSz="457200" rtl="0" eaLnBrk="1" latinLnBrk="0" hangingPunct="1">
       <a:defRPr sz="1800" kern="1200">
         <a:solidFill>
           <a:schemeClr val="tx1"/>
@@ -76,7 +76,7 @@
         <a:cs typeface="+mn-cs"/>
       </a:defRPr>
     </a:lvl6pPr>
-    <a:lvl7pPr marL="2743200" algn="l" defTabSz="914400" rtl="0" eaLnBrk="1" latinLnBrk="0" hangingPunct="1">
+    <a:lvl7pPr marL="2743200" algn="l" defTabSz="457200" rtl="0" eaLnBrk="1" latinLnBrk="0" hangingPunct="1">
       <a:defRPr sz="1800" kern="1200">
         <a:solidFill>
           <a:schemeClr val="tx1"/>
@@ -86,7 +86,7 @@
         <a:cs typeface="+mn-cs"/>
       </a:defRPr>
     </a:lvl7pPr>
-    <a:lvl8pPr marL="3200400" algn="l" defTabSz="914400" rtl="0" eaLnBrk="1" latinLnBrk="0" hangingPunct="1">
+    <a:lvl8pPr marL="3200400" algn="l" defTabSz="457200" rtl="0" eaLnBrk="1" latinLnBrk="0" hangingPunct="1">
       <a:defRPr sz="1800" kern="1200">
         <a:solidFill>
           <a:schemeClr val="tx1"/>
@@ -96,7 +96,7 @@
         <a:cs typeface="+mn-cs"/>
       </a:defRPr>
     </a:lvl8pPr>
-    <a:lvl9pPr marL="3657600" algn="l" defTabSz="914400" rtl="0" eaLnBrk="1" latinLnBrk="0" hangingPunct="1">
+    <a:lvl9pPr marL="3657600" algn="l" defTabSz="457200" rtl="0" eaLnBrk="1" latinLnBrk="0" hangingPunct="1">
       <a:defRPr sz="1800" kern="1200">
         <a:solidFill>
           <a:schemeClr val="tx1"/>
@@ -197,7 +197,7 @@
           <a:p>
             <a:fld id="{2ED0050D-EFD3-450D-ABD5-0019C5970CF9}" type="datetimeFigureOut">
               <a:rPr lang="de-AT" smtClean="0"/>
-              <a:t>20.02.2026</a:t>
+              <a:t>21.02.2026</a:t>
             </a:fld>
             <a:endParaRPr lang="de-AT"/>
           </a:p>
@@ -215,8 +215,8 @@
         </p:nvSpPr>
         <p:spPr>
           <a:xfrm>
-            <a:off x="685800" y="1143000"/>
-            <a:ext cx="5486400" cy="3086100"/>
+            <a:off x="1652588" y="1143000"/>
+            <a:ext cx="3552825" cy="3086100"/>
           </a:xfrm>
           <a:prstGeom prst="rect">
             <a:avLst/>
@@ -371,8 +371,8 @@
   </p:cSld>
   <p:clrMap bg1="lt1" tx1="dk1" bg2="lt2" tx2="dk2" accent1="accent1" accent2="accent2" accent3="accent3" accent4="accent4" accent5="accent5" accent6="accent6" hlink="hlink" folHlink="folHlink"/>
   <p:notesStyle>
-    <a:lvl1pPr marL="0" algn="l" defTabSz="914400" rtl="0" eaLnBrk="1" latinLnBrk="0" hangingPunct="1">
-      <a:defRPr sz="1200" kern="1200">
+    <a:lvl1pPr marL="0" algn="l" defTabSz="839694" rtl="0" eaLnBrk="1" latinLnBrk="0" hangingPunct="1">
+      <a:defRPr sz="1102" kern="1200">
         <a:solidFill>
           <a:schemeClr val="tx1"/>
         </a:solidFill>
@@ -381,8 +381,8 @@
         <a:cs typeface="+mn-cs"/>
       </a:defRPr>
     </a:lvl1pPr>
-    <a:lvl2pPr marL="457200" algn="l" defTabSz="914400" rtl="0" eaLnBrk="1" latinLnBrk="0" hangingPunct="1">
-      <a:defRPr sz="1200" kern="1200">
+    <a:lvl2pPr marL="419847" algn="l" defTabSz="839694" rtl="0" eaLnBrk="1" latinLnBrk="0" hangingPunct="1">
+      <a:defRPr sz="1102" kern="1200">
         <a:solidFill>
           <a:schemeClr val="tx1"/>
         </a:solidFill>
@@ -391,8 +391,8 @@
         <a:cs typeface="+mn-cs"/>
       </a:defRPr>
     </a:lvl2pPr>
-    <a:lvl3pPr marL="914400" algn="l" defTabSz="914400" rtl="0" eaLnBrk="1" latinLnBrk="0" hangingPunct="1">
-      <a:defRPr sz="1200" kern="1200">
+    <a:lvl3pPr marL="839694" algn="l" defTabSz="839694" rtl="0" eaLnBrk="1" latinLnBrk="0" hangingPunct="1">
+      <a:defRPr sz="1102" kern="1200">
         <a:solidFill>
           <a:schemeClr val="tx1"/>
         </a:solidFill>
@@ -401,8 +401,8 @@
         <a:cs typeface="+mn-cs"/>
       </a:defRPr>
     </a:lvl3pPr>
-    <a:lvl4pPr marL="1371600" algn="l" defTabSz="914400" rtl="0" eaLnBrk="1" latinLnBrk="0" hangingPunct="1">
-      <a:defRPr sz="1200" kern="1200">
+    <a:lvl4pPr marL="1259540" algn="l" defTabSz="839694" rtl="0" eaLnBrk="1" latinLnBrk="0" hangingPunct="1">
+      <a:defRPr sz="1102" kern="1200">
         <a:solidFill>
           <a:schemeClr val="tx1"/>
         </a:solidFill>
@@ -411,8 +411,8 @@
         <a:cs typeface="+mn-cs"/>
       </a:defRPr>
     </a:lvl4pPr>
-    <a:lvl5pPr marL="1828800" algn="l" defTabSz="914400" rtl="0" eaLnBrk="1" latinLnBrk="0" hangingPunct="1">
-      <a:defRPr sz="1200" kern="1200">
+    <a:lvl5pPr marL="1679387" algn="l" defTabSz="839694" rtl="0" eaLnBrk="1" latinLnBrk="0" hangingPunct="1">
+      <a:defRPr sz="1102" kern="1200">
         <a:solidFill>
           <a:schemeClr val="tx1"/>
         </a:solidFill>
@@ -421,8 +421,8 @@
         <a:cs typeface="+mn-cs"/>
       </a:defRPr>
     </a:lvl5pPr>
-    <a:lvl6pPr marL="2286000" algn="l" defTabSz="914400" rtl="0" eaLnBrk="1" latinLnBrk="0" hangingPunct="1">
-      <a:defRPr sz="1200" kern="1200">
+    <a:lvl6pPr marL="2099234" algn="l" defTabSz="839694" rtl="0" eaLnBrk="1" latinLnBrk="0" hangingPunct="1">
+      <a:defRPr sz="1102" kern="1200">
         <a:solidFill>
           <a:schemeClr val="tx1"/>
         </a:solidFill>
@@ -431,8 +431,8 @@
         <a:cs typeface="+mn-cs"/>
       </a:defRPr>
     </a:lvl6pPr>
-    <a:lvl7pPr marL="2743200" algn="l" defTabSz="914400" rtl="0" eaLnBrk="1" latinLnBrk="0" hangingPunct="1">
-      <a:defRPr sz="1200" kern="1200">
+    <a:lvl7pPr marL="2519081" algn="l" defTabSz="839694" rtl="0" eaLnBrk="1" latinLnBrk="0" hangingPunct="1">
+      <a:defRPr sz="1102" kern="1200">
         <a:solidFill>
           <a:schemeClr val="tx1"/>
         </a:solidFill>
@@ -441,8 +441,8 @@
         <a:cs typeface="+mn-cs"/>
       </a:defRPr>
     </a:lvl7pPr>
-    <a:lvl8pPr marL="3200400" algn="l" defTabSz="914400" rtl="0" eaLnBrk="1" latinLnBrk="0" hangingPunct="1">
-      <a:defRPr sz="1200" kern="1200">
+    <a:lvl8pPr marL="2938927" algn="l" defTabSz="839694" rtl="0" eaLnBrk="1" latinLnBrk="0" hangingPunct="1">
+      <a:defRPr sz="1102" kern="1200">
         <a:solidFill>
           <a:schemeClr val="tx1"/>
         </a:solidFill>
@@ -451,8 +451,8 @@
         <a:cs typeface="+mn-cs"/>
       </a:defRPr>
     </a:lvl8pPr>
-    <a:lvl9pPr marL="3657600" algn="l" defTabSz="914400" rtl="0" eaLnBrk="1" latinLnBrk="0" hangingPunct="1">
-      <a:defRPr sz="1200" kern="1200">
+    <a:lvl9pPr marL="3358774" algn="l" defTabSz="839694" rtl="0" eaLnBrk="1" latinLnBrk="0" hangingPunct="1">
+      <a:defRPr sz="1102" kern="1200">
         <a:solidFill>
           <a:schemeClr val="tx1"/>
         </a:solidFill>
@@ -492,7 +492,12 @@
             <p:ph type="sldImg"/>
           </p:nvPr>
         </p:nvSpPr>
-        <p:spPr/>
+        <p:spPr>
+          <a:xfrm>
+            <a:off x="1652588" y="1143000"/>
+            <a:ext cx="3552825" cy="3086100"/>
+          </a:xfrm>
+        </p:spPr>
       </p:sp>
       <p:sp>
         <p:nvSpPr>
@@ -568,13 +573,7 @@
       </p:grpSpPr>
       <p:sp>
         <p:nvSpPr>
-          <p:cNvPr id="2" name="Titel 1">
-            <a:extLst>
-              <a:ext uri="{FF2B5EF4-FFF2-40B4-BE49-F238E27FC236}">
-                <a16:creationId xmlns:a16="http://schemas.microsoft.com/office/drawing/2014/main" id="{33AEB34F-2832-B3EC-6EE6-342C463BC3D8}"/>
-              </a:ext>
-            </a:extLst>
-          </p:cNvPr>
+          <p:cNvPr id="2" name="Title 1"/>
           <p:cNvSpPr>
             <a:spLocks noGrp="1"/>
           </p:cNvSpPr>
@@ -584,15 +583,15 @@
         </p:nvSpPr>
         <p:spPr>
           <a:xfrm>
-            <a:off x="1524000" y="1122363"/>
-            <a:ext cx="9144000" cy="2387600"/>
+            <a:off x="589717" y="1118206"/>
+            <a:ext cx="6683455" cy="2378757"/>
           </a:xfrm>
         </p:spPr>
         <p:txBody>
           <a:bodyPr anchor="b"/>
           <a:lstStyle>
             <a:lvl1pPr algn="ctr">
-              <a:defRPr sz="6000"/>
+              <a:defRPr sz="5159"/>
             </a:lvl1pPr>
           </a:lstStyle>
           <a:p>
@@ -600,19 +599,13 @@
               <a:rPr lang="de-DE"/>
               <a:t>Mastertitelformat bearbeiten</a:t>
             </a:r>
-            <a:endParaRPr lang="de-AT"/>
-          </a:p>
-        </p:txBody>
-      </p:sp>
-      <p:sp>
-        <p:nvSpPr>
-          <p:cNvPr id="3" name="Untertitel 2">
-            <a:extLst>
-              <a:ext uri="{FF2B5EF4-FFF2-40B4-BE49-F238E27FC236}">
-                <a16:creationId xmlns:a16="http://schemas.microsoft.com/office/drawing/2014/main" id="{BE35C162-57BC-FB02-73A9-472A1DEC2D31}"/>
-              </a:ext>
-            </a:extLst>
-          </p:cNvPr>
+            <a:endParaRPr lang="en-US" dirty="0"/>
+          </a:p>
+        </p:txBody>
+      </p:sp>
+      <p:sp>
+        <p:nvSpPr>
+          <p:cNvPr id="3" name="Subtitle 2"/>
           <p:cNvSpPr>
             <a:spLocks noGrp="1"/>
           </p:cNvSpPr>
@@ -622,8 +615,8 @@
         </p:nvSpPr>
         <p:spPr>
           <a:xfrm>
-            <a:off x="1524000" y="3602038"/>
-            <a:ext cx="9144000" cy="1655762"/>
+            <a:off x="982861" y="3588697"/>
+            <a:ext cx="5897166" cy="1649630"/>
           </a:xfrm>
         </p:spPr>
         <p:txBody>
@@ -631,39 +624,39 @@
           <a:lstStyle>
             <a:lvl1pPr marL="0" indent="0" algn="ctr">
               <a:buNone/>
-              <a:defRPr sz="2400"/>
+              <a:defRPr sz="2064"/>
             </a:lvl1pPr>
-            <a:lvl2pPr marL="457200" indent="0" algn="ctr">
-              <a:buNone/>
-              <a:defRPr sz="2000"/>
+            <a:lvl2pPr marL="393146" indent="0" algn="ctr">
+              <a:buNone/>
+              <a:defRPr sz="1720"/>
             </a:lvl2pPr>
-            <a:lvl3pPr marL="914400" indent="0" algn="ctr">
-              <a:buNone/>
-              <a:defRPr sz="1800"/>
+            <a:lvl3pPr marL="786293" indent="0" algn="ctr">
+              <a:buNone/>
+              <a:defRPr sz="1548"/>
             </a:lvl3pPr>
-            <a:lvl4pPr marL="1371600" indent="0" algn="ctr">
-              <a:buNone/>
-              <a:defRPr sz="1600"/>
+            <a:lvl4pPr marL="1179439" indent="0" algn="ctr">
+              <a:buNone/>
+              <a:defRPr sz="1376"/>
             </a:lvl4pPr>
-            <a:lvl5pPr marL="1828800" indent="0" algn="ctr">
-              <a:buNone/>
-              <a:defRPr sz="1600"/>
+            <a:lvl5pPr marL="1572585" indent="0" algn="ctr">
+              <a:buNone/>
+              <a:defRPr sz="1376"/>
             </a:lvl5pPr>
-            <a:lvl6pPr marL="2286000" indent="0" algn="ctr">
-              <a:buNone/>
-              <a:defRPr sz="1600"/>
+            <a:lvl6pPr marL="1965731" indent="0" algn="ctr">
+              <a:buNone/>
+              <a:defRPr sz="1376"/>
             </a:lvl6pPr>
-            <a:lvl7pPr marL="2743200" indent="0" algn="ctr">
-              <a:buNone/>
-              <a:defRPr sz="1600"/>
+            <a:lvl7pPr marL="2358878" indent="0" algn="ctr">
+              <a:buNone/>
+              <a:defRPr sz="1376"/>
             </a:lvl7pPr>
-            <a:lvl8pPr marL="3200400" indent="0" algn="ctr">
-              <a:buNone/>
-              <a:defRPr sz="1600"/>
+            <a:lvl8pPr marL="2752024" indent="0" algn="ctr">
+              <a:buNone/>
+              <a:defRPr sz="1376"/>
             </a:lvl8pPr>
-            <a:lvl9pPr marL="3657600" indent="0" algn="ctr">
-              <a:buNone/>
-              <a:defRPr sz="1600"/>
+            <a:lvl9pPr marL="3145170" indent="0" algn="ctr">
+              <a:buNone/>
+              <a:defRPr sz="1376"/>
             </a:lvl9pPr>
           </a:lstStyle>
           <a:p>
@@ -671,19 +664,13 @@
               <a:rPr lang="de-DE"/>
               <a:t>Master-Untertitelformat bearbeiten</a:t>
             </a:r>
-            <a:endParaRPr lang="de-AT"/>
-          </a:p>
-        </p:txBody>
-      </p:sp>
-      <p:sp>
-        <p:nvSpPr>
-          <p:cNvPr id="4" name="Datumsplatzhalter 3">
-            <a:extLst>
-              <a:ext uri="{FF2B5EF4-FFF2-40B4-BE49-F238E27FC236}">
-                <a16:creationId xmlns:a16="http://schemas.microsoft.com/office/drawing/2014/main" id="{FEC7915B-C8A8-A435-98FE-E58FAC18C32A}"/>
-              </a:ext>
-            </a:extLst>
-          </p:cNvPr>
+            <a:endParaRPr lang="en-US" dirty="0"/>
+          </a:p>
+        </p:txBody>
+      </p:sp>
+      <p:sp>
+        <p:nvSpPr>
+          <p:cNvPr id="4" name="Date Placeholder 3"/>
           <p:cNvSpPr>
             <a:spLocks noGrp="1"/>
           </p:cNvSpPr>
@@ -698,7 +685,7 @@
           <a:p>
             <a:fld id="{0E4C2A6E-34C0-4481-B3D7-04230C49192B}" type="datetimeFigureOut">
               <a:rPr lang="de-AT" smtClean="0"/>
-              <a:t>20.02.2026</a:t>
+              <a:t>21.02.2026</a:t>
             </a:fld>
             <a:endParaRPr lang="de-AT"/>
           </a:p>
@@ -706,13 +693,7 @@
       </p:sp>
       <p:sp>
         <p:nvSpPr>
-          <p:cNvPr id="5" name="Fußzeilenplatzhalter 4">
-            <a:extLst>
-              <a:ext uri="{FF2B5EF4-FFF2-40B4-BE49-F238E27FC236}">
-                <a16:creationId xmlns:a16="http://schemas.microsoft.com/office/drawing/2014/main" id="{2589FFEB-77EF-5FF6-EBF3-61A37444CFE3}"/>
-              </a:ext>
-            </a:extLst>
-          </p:cNvPr>
+          <p:cNvPr id="5" name="Footer Placeholder 4"/>
           <p:cNvSpPr>
             <a:spLocks noGrp="1"/>
           </p:cNvSpPr>
@@ -731,13 +712,7 @@
       </p:sp>
       <p:sp>
         <p:nvSpPr>
-          <p:cNvPr id="6" name="Foliennummernplatzhalter 5">
-            <a:extLst>
-              <a:ext uri="{FF2B5EF4-FFF2-40B4-BE49-F238E27FC236}">
-                <a16:creationId xmlns:a16="http://schemas.microsoft.com/office/drawing/2014/main" id="{7550ADE0-9A27-0129-1840-D12707CF4E4D}"/>
-              </a:ext>
-            </a:extLst>
-          </p:cNvPr>
+          <p:cNvPr id="6" name="Slide Number Placeholder 5"/>
           <p:cNvSpPr>
             <a:spLocks noGrp="1"/>
           </p:cNvSpPr>
@@ -761,7 +736,7 @@
     </p:spTree>
     <p:extLst>
       <p:ext uri="{BB962C8B-B14F-4D97-AF65-F5344CB8AC3E}">
-        <p14:creationId xmlns:p14="http://schemas.microsoft.com/office/powerpoint/2010/main" val="3444571247"/>
+        <p14:creationId xmlns:p14="http://schemas.microsoft.com/office/powerpoint/2010/main" val="3624932318"/>
       </p:ext>
     </p:extLst>
   </p:cSld>
@@ -790,13 +765,7 @@
       </p:grpSpPr>
       <p:sp>
         <p:nvSpPr>
-          <p:cNvPr id="2" name="Titel 1">
-            <a:extLst>
-              <a:ext uri="{FF2B5EF4-FFF2-40B4-BE49-F238E27FC236}">
-                <a16:creationId xmlns:a16="http://schemas.microsoft.com/office/drawing/2014/main" id="{D1C3DC29-FF02-6F70-2441-8748C792ED25}"/>
-              </a:ext>
-            </a:extLst>
-          </p:cNvPr>
+          <p:cNvPr id="2" name="Title 1"/>
           <p:cNvSpPr>
             <a:spLocks noGrp="1"/>
           </p:cNvSpPr>
@@ -813,19 +782,13 @@
               <a:rPr lang="de-DE"/>
               <a:t>Mastertitelformat bearbeiten</a:t>
             </a:r>
-            <a:endParaRPr lang="de-AT"/>
-          </a:p>
-        </p:txBody>
-      </p:sp>
-      <p:sp>
-        <p:nvSpPr>
-          <p:cNvPr id="3" name="Vertikaler Textplatzhalter 2">
-            <a:extLst>
-              <a:ext uri="{FF2B5EF4-FFF2-40B4-BE49-F238E27FC236}">
-                <a16:creationId xmlns:a16="http://schemas.microsoft.com/office/drawing/2014/main" id="{C9C2DCD4-9928-66E2-14A4-8A4E95AE5B68}"/>
-              </a:ext>
-            </a:extLst>
-          </p:cNvPr>
+            <a:endParaRPr lang="en-US" dirty="0"/>
+          </a:p>
+        </p:txBody>
+      </p:sp>
+      <p:sp>
+        <p:nvSpPr>
+          <p:cNvPr id="3" name="Vertical Text Placeholder 2"/>
           <p:cNvSpPr>
             <a:spLocks noGrp="1"/>
           </p:cNvSpPr>
@@ -871,19 +834,13 @@
               <a:rPr lang="de-DE"/>
               <a:t>Fünfte Ebene</a:t>
             </a:r>
-            <a:endParaRPr lang="de-AT"/>
-          </a:p>
-        </p:txBody>
-      </p:sp>
-      <p:sp>
-        <p:nvSpPr>
-          <p:cNvPr id="4" name="Datumsplatzhalter 3">
-            <a:extLst>
-              <a:ext uri="{FF2B5EF4-FFF2-40B4-BE49-F238E27FC236}">
-                <a16:creationId xmlns:a16="http://schemas.microsoft.com/office/drawing/2014/main" id="{27A20518-AB73-96E0-02FA-09FB28682B57}"/>
-              </a:ext>
-            </a:extLst>
-          </p:cNvPr>
+            <a:endParaRPr lang="en-US" dirty="0"/>
+          </a:p>
+        </p:txBody>
+      </p:sp>
+      <p:sp>
+        <p:nvSpPr>
+          <p:cNvPr id="4" name="Date Placeholder 3"/>
           <p:cNvSpPr>
             <a:spLocks noGrp="1"/>
           </p:cNvSpPr>
@@ -898,7 +855,7 @@
           <a:p>
             <a:fld id="{0E4C2A6E-34C0-4481-B3D7-04230C49192B}" type="datetimeFigureOut">
               <a:rPr lang="de-AT" smtClean="0"/>
-              <a:t>20.02.2026</a:t>
+              <a:t>21.02.2026</a:t>
             </a:fld>
             <a:endParaRPr lang="de-AT"/>
           </a:p>
@@ -906,13 +863,7 @@
       </p:sp>
       <p:sp>
         <p:nvSpPr>
-          <p:cNvPr id="5" name="Fußzeilenplatzhalter 4">
-            <a:extLst>
-              <a:ext uri="{FF2B5EF4-FFF2-40B4-BE49-F238E27FC236}">
-                <a16:creationId xmlns:a16="http://schemas.microsoft.com/office/drawing/2014/main" id="{EA2DA9B2-5362-1689-AA1B-338742D16E7F}"/>
-              </a:ext>
-            </a:extLst>
-          </p:cNvPr>
+          <p:cNvPr id="5" name="Footer Placeholder 4"/>
           <p:cNvSpPr>
             <a:spLocks noGrp="1"/>
           </p:cNvSpPr>
@@ -931,13 +882,7 @@
       </p:sp>
       <p:sp>
         <p:nvSpPr>
-          <p:cNvPr id="6" name="Foliennummernplatzhalter 5">
-            <a:extLst>
-              <a:ext uri="{FF2B5EF4-FFF2-40B4-BE49-F238E27FC236}">
-                <a16:creationId xmlns:a16="http://schemas.microsoft.com/office/drawing/2014/main" id="{F3239367-E66D-F03A-DB42-AA14E2B3A7A7}"/>
-              </a:ext>
-            </a:extLst>
-          </p:cNvPr>
+          <p:cNvPr id="6" name="Slide Number Placeholder 5"/>
           <p:cNvSpPr>
             <a:spLocks noGrp="1"/>
           </p:cNvSpPr>
@@ -961,7 +906,7 @@
     </p:spTree>
     <p:extLst>
       <p:ext uri="{BB962C8B-B14F-4D97-AF65-F5344CB8AC3E}">
-        <p14:creationId xmlns:p14="http://schemas.microsoft.com/office/powerpoint/2010/main" val="1474687025"/>
+        <p14:creationId xmlns:p14="http://schemas.microsoft.com/office/powerpoint/2010/main" val="2608569859"/>
       </p:ext>
     </p:extLst>
   </p:cSld>
@@ -990,13 +935,7 @@
       </p:grpSpPr>
       <p:sp>
         <p:nvSpPr>
-          <p:cNvPr id="2" name="Vertikaler Titel 1">
-            <a:extLst>
-              <a:ext uri="{FF2B5EF4-FFF2-40B4-BE49-F238E27FC236}">
-                <a16:creationId xmlns:a16="http://schemas.microsoft.com/office/drawing/2014/main" id="{3F4BF16B-B526-798E-D4A0-92E8D94FE4D9}"/>
-              </a:ext>
-            </a:extLst>
-          </p:cNvPr>
+          <p:cNvPr id="2" name="Vertical Title 1"/>
           <p:cNvSpPr>
             <a:spLocks noGrp="1"/>
           </p:cNvSpPr>
@@ -1006,8 +945,8 @@
         </p:nvSpPr>
         <p:spPr>
           <a:xfrm>
-            <a:off x="8724900" y="365125"/>
-            <a:ext cx="2628900" cy="5811838"/>
+            <a:off x="5626880" y="363773"/>
+            <a:ext cx="1695435" cy="5790313"/>
           </a:xfrm>
         </p:spPr>
         <p:txBody>
@@ -1018,19 +957,13 @@
               <a:rPr lang="de-DE"/>
               <a:t>Mastertitelformat bearbeiten</a:t>
             </a:r>
-            <a:endParaRPr lang="de-AT"/>
-          </a:p>
-        </p:txBody>
-      </p:sp>
-      <p:sp>
-        <p:nvSpPr>
-          <p:cNvPr id="3" name="Vertikaler Textplatzhalter 2">
-            <a:extLst>
-              <a:ext uri="{FF2B5EF4-FFF2-40B4-BE49-F238E27FC236}">
-                <a16:creationId xmlns:a16="http://schemas.microsoft.com/office/drawing/2014/main" id="{E7C9B4D5-5F15-03AB-4273-01DD326982CF}"/>
-              </a:ext>
-            </a:extLst>
-          </p:cNvPr>
+            <a:endParaRPr lang="en-US" dirty="0"/>
+          </a:p>
+        </p:txBody>
+      </p:sp>
+      <p:sp>
+        <p:nvSpPr>
+          <p:cNvPr id="3" name="Vertical Text Placeholder 2"/>
           <p:cNvSpPr>
             <a:spLocks noGrp="1"/>
           </p:cNvSpPr>
@@ -1040,8 +973,8 @@
         </p:nvSpPr>
         <p:spPr>
           <a:xfrm>
-            <a:off x="838200" y="365125"/>
-            <a:ext cx="7734300" cy="5811838"/>
+            <a:off x="540574" y="363773"/>
+            <a:ext cx="4988020" cy="5790313"/>
           </a:xfrm>
         </p:spPr>
         <p:txBody>
@@ -1081,19 +1014,13 @@
               <a:rPr lang="de-DE"/>
               <a:t>Fünfte Ebene</a:t>
             </a:r>
-            <a:endParaRPr lang="de-AT"/>
-          </a:p>
-        </p:txBody>
-      </p:sp>
-      <p:sp>
-        <p:nvSpPr>
-          <p:cNvPr id="4" name="Datumsplatzhalter 3">
-            <a:extLst>
-              <a:ext uri="{FF2B5EF4-FFF2-40B4-BE49-F238E27FC236}">
-                <a16:creationId xmlns:a16="http://schemas.microsoft.com/office/drawing/2014/main" id="{DBB6D2FB-46C5-D9FA-B7F3-645255A4CA7D}"/>
-              </a:ext>
-            </a:extLst>
-          </p:cNvPr>
+            <a:endParaRPr lang="en-US" dirty="0"/>
+          </a:p>
+        </p:txBody>
+      </p:sp>
+      <p:sp>
+        <p:nvSpPr>
+          <p:cNvPr id="4" name="Date Placeholder 3"/>
           <p:cNvSpPr>
             <a:spLocks noGrp="1"/>
           </p:cNvSpPr>
@@ -1108,7 +1035,7 @@
           <a:p>
             <a:fld id="{0E4C2A6E-34C0-4481-B3D7-04230C49192B}" type="datetimeFigureOut">
               <a:rPr lang="de-AT" smtClean="0"/>
-              <a:t>20.02.2026</a:t>
+              <a:t>21.02.2026</a:t>
             </a:fld>
             <a:endParaRPr lang="de-AT"/>
           </a:p>
@@ -1116,13 +1043,7 @@
       </p:sp>
       <p:sp>
         <p:nvSpPr>
-          <p:cNvPr id="5" name="Fußzeilenplatzhalter 4">
-            <a:extLst>
-              <a:ext uri="{FF2B5EF4-FFF2-40B4-BE49-F238E27FC236}">
-                <a16:creationId xmlns:a16="http://schemas.microsoft.com/office/drawing/2014/main" id="{222BCE7F-E0F8-461C-9022-CDE78FE75210}"/>
-              </a:ext>
-            </a:extLst>
-          </p:cNvPr>
+          <p:cNvPr id="5" name="Footer Placeholder 4"/>
           <p:cNvSpPr>
             <a:spLocks noGrp="1"/>
           </p:cNvSpPr>
@@ -1141,13 +1062,7 @@
       </p:sp>
       <p:sp>
         <p:nvSpPr>
-          <p:cNvPr id="6" name="Foliennummernplatzhalter 5">
-            <a:extLst>
-              <a:ext uri="{FF2B5EF4-FFF2-40B4-BE49-F238E27FC236}">
-                <a16:creationId xmlns:a16="http://schemas.microsoft.com/office/drawing/2014/main" id="{8614C524-B714-2AFD-4729-016D3C04DE93}"/>
-              </a:ext>
-            </a:extLst>
-          </p:cNvPr>
+          <p:cNvPr id="6" name="Slide Number Placeholder 5"/>
           <p:cNvSpPr>
             <a:spLocks noGrp="1"/>
           </p:cNvSpPr>
@@ -1171,7 +1086,7 @@
     </p:spTree>
     <p:extLst>
       <p:ext uri="{BB962C8B-B14F-4D97-AF65-F5344CB8AC3E}">
-        <p14:creationId xmlns:p14="http://schemas.microsoft.com/office/powerpoint/2010/main" val="3238561203"/>
+        <p14:creationId xmlns:p14="http://schemas.microsoft.com/office/powerpoint/2010/main" val="2807806673"/>
       </p:ext>
     </p:extLst>
   </p:cSld>
@@ -1200,13 +1115,7 @@
       </p:grpSpPr>
       <p:sp>
         <p:nvSpPr>
-          <p:cNvPr id="2" name="Titel 1">
-            <a:extLst>
-              <a:ext uri="{FF2B5EF4-FFF2-40B4-BE49-F238E27FC236}">
-                <a16:creationId xmlns:a16="http://schemas.microsoft.com/office/drawing/2014/main" id="{42086BF3-E81D-5364-AA95-4166D6BEDCB8}"/>
-              </a:ext>
-            </a:extLst>
-          </p:cNvPr>
+          <p:cNvPr id="2" name="Title 1"/>
           <p:cNvSpPr>
             <a:spLocks noGrp="1"/>
           </p:cNvSpPr>
@@ -1223,19 +1132,13 @@
               <a:rPr lang="de-DE"/>
               <a:t>Mastertitelformat bearbeiten</a:t>
             </a:r>
-            <a:endParaRPr lang="de-AT"/>
-          </a:p>
-        </p:txBody>
-      </p:sp>
-      <p:sp>
-        <p:nvSpPr>
-          <p:cNvPr id="3" name="Inhaltsplatzhalter 2">
-            <a:extLst>
-              <a:ext uri="{FF2B5EF4-FFF2-40B4-BE49-F238E27FC236}">
-                <a16:creationId xmlns:a16="http://schemas.microsoft.com/office/drawing/2014/main" id="{EEBE461C-3C4A-57F4-ED98-E04242D6CEC0}"/>
-              </a:ext>
-            </a:extLst>
-          </p:cNvPr>
+            <a:endParaRPr lang="en-US" dirty="0"/>
+          </a:p>
+        </p:txBody>
+      </p:sp>
+      <p:sp>
+        <p:nvSpPr>
+          <p:cNvPr id="3" name="Content Placeholder 2"/>
           <p:cNvSpPr>
             <a:spLocks noGrp="1"/>
           </p:cNvSpPr>
@@ -1281,19 +1184,13 @@
               <a:rPr lang="de-DE"/>
               <a:t>Fünfte Ebene</a:t>
             </a:r>
-            <a:endParaRPr lang="de-AT"/>
-          </a:p>
-        </p:txBody>
-      </p:sp>
-      <p:sp>
-        <p:nvSpPr>
-          <p:cNvPr id="4" name="Datumsplatzhalter 3">
-            <a:extLst>
-              <a:ext uri="{FF2B5EF4-FFF2-40B4-BE49-F238E27FC236}">
-                <a16:creationId xmlns:a16="http://schemas.microsoft.com/office/drawing/2014/main" id="{0F746ABF-5D3B-8553-7537-132A27C60E7F}"/>
-              </a:ext>
-            </a:extLst>
-          </p:cNvPr>
+            <a:endParaRPr lang="en-US" dirty="0"/>
+          </a:p>
+        </p:txBody>
+      </p:sp>
+      <p:sp>
+        <p:nvSpPr>
+          <p:cNvPr id="4" name="Date Placeholder 3"/>
           <p:cNvSpPr>
             <a:spLocks noGrp="1"/>
           </p:cNvSpPr>
@@ -1308,7 +1205,7 @@
           <a:p>
             <a:fld id="{0E4C2A6E-34C0-4481-B3D7-04230C49192B}" type="datetimeFigureOut">
               <a:rPr lang="de-AT" smtClean="0"/>
-              <a:t>20.02.2026</a:t>
+              <a:t>21.02.2026</a:t>
             </a:fld>
             <a:endParaRPr lang="de-AT"/>
           </a:p>
@@ -1316,13 +1213,7 @@
       </p:sp>
       <p:sp>
         <p:nvSpPr>
-          <p:cNvPr id="5" name="Fußzeilenplatzhalter 4">
-            <a:extLst>
-              <a:ext uri="{FF2B5EF4-FFF2-40B4-BE49-F238E27FC236}">
-                <a16:creationId xmlns:a16="http://schemas.microsoft.com/office/drawing/2014/main" id="{F695D137-C7D6-9E48-ACD0-3EC1E719C93F}"/>
-              </a:ext>
-            </a:extLst>
-          </p:cNvPr>
+          <p:cNvPr id="5" name="Footer Placeholder 4"/>
           <p:cNvSpPr>
             <a:spLocks noGrp="1"/>
           </p:cNvSpPr>
@@ -1341,13 +1232,7 @@
       </p:sp>
       <p:sp>
         <p:nvSpPr>
-          <p:cNvPr id="6" name="Foliennummernplatzhalter 5">
-            <a:extLst>
-              <a:ext uri="{FF2B5EF4-FFF2-40B4-BE49-F238E27FC236}">
-                <a16:creationId xmlns:a16="http://schemas.microsoft.com/office/drawing/2014/main" id="{1BE35E4D-7674-B2AF-DF57-CB124AC8CE2B}"/>
-              </a:ext>
-            </a:extLst>
-          </p:cNvPr>
+          <p:cNvPr id="6" name="Slide Number Placeholder 5"/>
           <p:cNvSpPr>
             <a:spLocks noGrp="1"/>
           </p:cNvSpPr>
@@ -1371,7 +1256,7 @@
     </p:spTree>
     <p:extLst>
       <p:ext uri="{BB962C8B-B14F-4D97-AF65-F5344CB8AC3E}">
-        <p14:creationId xmlns:p14="http://schemas.microsoft.com/office/powerpoint/2010/main" val="2429746983"/>
+        <p14:creationId xmlns:p14="http://schemas.microsoft.com/office/powerpoint/2010/main" val="3597094103"/>
       </p:ext>
     </p:extLst>
   </p:cSld>
@@ -1400,13 +1285,7 @@
       </p:grpSpPr>
       <p:sp>
         <p:nvSpPr>
-          <p:cNvPr id="2" name="Titel 1">
-            <a:extLst>
-              <a:ext uri="{FF2B5EF4-FFF2-40B4-BE49-F238E27FC236}">
-                <a16:creationId xmlns:a16="http://schemas.microsoft.com/office/drawing/2014/main" id="{F3343A28-F1C9-0AD2-6667-7EEBC807731C}"/>
-              </a:ext>
-            </a:extLst>
-          </p:cNvPr>
+          <p:cNvPr id="2" name="Title 1"/>
           <p:cNvSpPr>
             <a:spLocks noGrp="1"/>
           </p:cNvSpPr>
@@ -1416,15 +1295,15 @@
         </p:nvSpPr>
         <p:spPr>
           <a:xfrm>
-            <a:off x="831850" y="1709738"/>
-            <a:ext cx="10515600" cy="2852737"/>
+            <a:off x="536479" y="1703407"/>
+            <a:ext cx="6781741" cy="2842171"/>
           </a:xfrm>
         </p:spPr>
         <p:txBody>
           <a:bodyPr anchor="b"/>
           <a:lstStyle>
             <a:lvl1pPr>
-              <a:defRPr sz="6000"/>
+              <a:defRPr sz="5159"/>
             </a:lvl1pPr>
           </a:lstStyle>
           <a:p>
@@ -1432,19 +1311,13 @@
               <a:rPr lang="de-DE"/>
               <a:t>Mastertitelformat bearbeiten</a:t>
             </a:r>
-            <a:endParaRPr lang="de-AT"/>
-          </a:p>
-        </p:txBody>
-      </p:sp>
-      <p:sp>
-        <p:nvSpPr>
-          <p:cNvPr id="3" name="Textplatzhalter 2">
-            <a:extLst>
-              <a:ext uri="{FF2B5EF4-FFF2-40B4-BE49-F238E27FC236}">
-                <a16:creationId xmlns:a16="http://schemas.microsoft.com/office/drawing/2014/main" id="{AE6A306D-601D-AF7C-5F62-6D6A7A61CAED}"/>
-              </a:ext>
-            </a:extLst>
-          </p:cNvPr>
+            <a:endParaRPr lang="en-US" dirty="0"/>
+          </a:p>
+        </p:txBody>
+      </p:sp>
+      <p:sp>
+        <p:nvSpPr>
+          <p:cNvPr id="3" name="Text Placeholder 2"/>
           <p:cNvSpPr>
             <a:spLocks noGrp="1"/>
           </p:cNvSpPr>
@@ -1454,8 +1327,8 @@
         </p:nvSpPr>
         <p:spPr>
           <a:xfrm>
-            <a:off x="831850" y="4589463"/>
-            <a:ext cx="10515600" cy="1500187"/>
+            <a:off x="536479" y="4572466"/>
+            <a:ext cx="6781741" cy="1494631"/>
           </a:xfrm>
         </p:spPr>
         <p:txBody>
@@ -1463,7 +1336,7 @@
           <a:lstStyle>
             <a:lvl1pPr marL="0" indent="0">
               <a:buNone/>
-              <a:defRPr sz="2400">
+              <a:defRPr sz="2064">
                 <a:solidFill>
                   <a:schemeClr val="tx1">
                     <a:tint val="82000"/>
@@ -1471,9 +1344,9 @@
                 </a:solidFill>
               </a:defRPr>
             </a:lvl1pPr>
-            <a:lvl2pPr marL="457200" indent="0">
-              <a:buNone/>
-              <a:defRPr sz="2000">
+            <a:lvl2pPr marL="393146" indent="0">
+              <a:buNone/>
+              <a:defRPr sz="1720">
                 <a:solidFill>
                   <a:schemeClr val="tx1">
                     <a:tint val="82000"/>
@@ -1481,9 +1354,9 @@
                 </a:solidFill>
               </a:defRPr>
             </a:lvl2pPr>
-            <a:lvl3pPr marL="914400" indent="0">
-              <a:buNone/>
-              <a:defRPr sz="1800">
+            <a:lvl3pPr marL="786293" indent="0">
+              <a:buNone/>
+              <a:defRPr sz="1548">
                 <a:solidFill>
                   <a:schemeClr val="tx1">
                     <a:tint val="82000"/>
@@ -1491,9 +1364,9 @@
                 </a:solidFill>
               </a:defRPr>
             </a:lvl3pPr>
-            <a:lvl4pPr marL="1371600" indent="0">
-              <a:buNone/>
-              <a:defRPr sz="1600">
+            <a:lvl4pPr marL="1179439" indent="0">
+              <a:buNone/>
+              <a:defRPr sz="1376">
                 <a:solidFill>
                   <a:schemeClr val="tx1">
                     <a:tint val="82000"/>
@@ -1501,9 +1374,9 @@
                 </a:solidFill>
               </a:defRPr>
             </a:lvl4pPr>
-            <a:lvl5pPr marL="1828800" indent="0">
-              <a:buNone/>
-              <a:defRPr sz="1600">
+            <a:lvl5pPr marL="1572585" indent="0">
+              <a:buNone/>
+              <a:defRPr sz="1376">
                 <a:solidFill>
                   <a:schemeClr val="tx1">
                     <a:tint val="82000"/>
@@ -1511,9 +1384,9 @@
                 </a:solidFill>
               </a:defRPr>
             </a:lvl5pPr>
-            <a:lvl6pPr marL="2286000" indent="0">
-              <a:buNone/>
-              <a:defRPr sz="1600">
+            <a:lvl6pPr marL="1965731" indent="0">
+              <a:buNone/>
+              <a:defRPr sz="1376">
                 <a:solidFill>
                   <a:schemeClr val="tx1">
                     <a:tint val="82000"/>
@@ -1521,9 +1394,9 @@
                 </a:solidFill>
               </a:defRPr>
             </a:lvl6pPr>
-            <a:lvl7pPr marL="2743200" indent="0">
-              <a:buNone/>
-              <a:defRPr sz="1600">
+            <a:lvl7pPr marL="2358878" indent="0">
+              <a:buNone/>
+              <a:defRPr sz="1376">
                 <a:solidFill>
                   <a:schemeClr val="tx1">
                     <a:tint val="82000"/>
@@ -1531,9 +1404,9 @@
                 </a:solidFill>
               </a:defRPr>
             </a:lvl7pPr>
-            <a:lvl8pPr marL="3200400" indent="0">
-              <a:buNone/>
-              <a:defRPr sz="1600">
+            <a:lvl8pPr marL="2752024" indent="0">
+              <a:buNone/>
+              <a:defRPr sz="1376">
                 <a:solidFill>
                   <a:schemeClr val="tx1">
                     <a:tint val="82000"/>
@@ -1541,9 +1414,9 @@
                 </a:solidFill>
               </a:defRPr>
             </a:lvl8pPr>
-            <a:lvl9pPr marL="3657600" indent="0">
-              <a:buNone/>
-              <a:defRPr sz="1600">
+            <a:lvl9pPr marL="3145170" indent="0">
+              <a:buNone/>
+              <a:defRPr sz="1376">
                 <a:solidFill>
                   <a:schemeClr val="tx1">
                     <a:tint val="82000"/>
@@ -1563,13 +1436,7 @@
       </p:sp>
       <p:sp>
         <p:nvSpPr>
-          <p:cNvPr id="4" name="Datumsplatzhalter 3">
-            <a:extLst>
-              <a:ext uri="{FF2B5EF4-FFF2-40B4-BE49-F238E27FC236}">
-                <a16:creationId xmlns:a16="http://schemas.microsoft.com/office/drawing/2014/main" id="{03C41551-00E7-CB90-7DD3-1074BBF28526}"/>
-              </a:ext>
-            </a:extLst>
-          </p:cNvPr>
+          <p:cNvPr id="4" name="Date Placeholder 3"/>
           <p:cNvSpPr>
             <a:spLocks noGrp="1"/>
           </p:cNvSpPr>
@@ -1584,7 +1451,7 @@
           <a:p>
             <a:fld id="{0E4C2A6E-34C0-4481-B3D7-04230C49192B}" type="datetimeFigureOut">
               <a:rPr lang="de-AT" smtClean="0"/>
-              <a:t>20.02.2026</a:t>
+              <a:t>21.02.2026</a:t>
             </a:fld>
             <a:endParaRPr lang="de-AT"/>
           </a:p>
@@ -1592,13 +1459,7 @@
       </p:sp>
       <p:sp>
         <p:nvSpPr>
-          <p:cNvPr id="5" name="Fußzeilenplatzhalter 4">
-            <a:extLst>
-              <a:ext uri="{FF2B5EF4-FFF2-40B4-BE49-F238E27FC236}">
-                <a16:creationId xmlns:a16="http://schemas.microsoft.com/office/drawing/2014/main" id="{AE68ECF6-3A12-E596-9C1E-7B4B895A6788}"/>
-              </a:ext>
-            </a:extLst>
-          </p:cNvPr>
+          <p:cNvPr id="5" name="Footer Placeholder 4"/>
           <p:cNvSpPr>
             <a:spLocks noGrp="1"/>
           </p:cNvSpPr>
@@ -1617,13 +1478,7 @@
       </p:sp>
       <p:sp>
         <p:nvSpPr>
-          <p:cNvPr id="6" name="Foliennummernplatzhalter 5">
-            <a:extLst>
-              <a:ext uri="{FF2B5EF4-FFF2-40B4-BE49-F238E27FC236}">
-                <a16:creationId xmlns:a16="http://schemas.microsoft.com/office/drawing/2014/main" id="{4FF80146-D3CF-4807-64F8-58BC0F4F2960}"/>
-              </a:ext>
-            </a:extLst>
-          </p:cNvPr>
+          <p:cNvPr id="6" name="Slide Number Placeholder 5"/>
           <p:cNvSpPr>
             <a:spLocks noGrp="1"/>
           </p:cNvSpPr>
@@ -1647,7 +1502,7 @@
     </p:spTree>
     <p:extLst>
       <p:ext uri="{BB962C8B-B14F-4D97-AF65-F5344CB8AC3E}">
-        <p14:creationId xmlns:p14="http://schemas.microsoft.com/office/powerpoint/2010/main" val="4078710251"/>
+        <p14:creationId xmlns:p14="http://schemas.microsoft.com/office/powerpoint/2010/main" val="1439661020"/>
       </p:ext>
     </p:extLst>
   </p:cSld>
@@ -1676,13 +1531,7 @@
       </p:grpSpPr>
       <p:sp>
         <p:nvSpPr>
-          <p:cNvPr id="2" name="Titel 1">
-            <a:extLst>
-              <a:ext uri="{FF2B5EF4-FFF2-40B4-BE49-F238E27FC236}">
-                <a16:creationId xmlns:a16="http://schemas.microsoft.com/office/drawing/2014/main" id="{02A88E78-DB80-5F0C-530F-242968931614}"/>
-              </a:ext>
-            </a:extLst>
-          </p:cNvPr>
+          <p:cNvPr id="2" name="Title 1"/>
           <p:cNvSpPr>
             <a:spLocks noGrp="1"/>
           </p:cNvSpPr>
@@ -1699,19 +1548,13 @@
               <a:rPr lang="de-DE"/>
               <a:t>Mastertitelformat bearbeiten</a:t>
             </a:r>
-            <a:endParaRPr lang="de-AT"/>
-          </a:p>
-        </p:txBody>
-      </p:sp>
-      <p:sp>
-        <p:nvSpPr>
-          <p:cNvPr id="3" name="Inhaltsplatzhalter 2">
-            <a:extLst>
-              <a:ext uri="{FF2B5EF4-FFF2-40B4-BE49-F238E27FC236}">
-                <a16:creationId xmlns:a16="http://schemas.microsoft.com/office/drawing/2014/main" id="{C13D86EA-E94B-DB8B-C709-787BC3F84290}"/>
-              </a:ext>
-            </a:extLst>
-          </p:cNvPr>
+            <a:endParaRPr lang="en-US" dirty="0"/>
+          </a:p>
+        </p:txBody>
+      </p:sp>
+      <p:sp>
+        <p:nvSpPr>
+          <p:cNvPr id="3" name="Content Placeholder 2"/>
           <p:cNvSpPr>
             <a:spLocks noGrp="1"/>
           </p:cNvSpPr>
@@ -1721,8 +1564,8 @@
         </p:nvSpPr>
         <p:spPr>
           <a:xfrm>
-            <a:off x="838200" y="1825625"/>
-            <a:ext cx="5181600" cy="4351338"/>
+            <a:off x="540574" y="1818863"/>
+            <a:ext cx="3341727" cy="4335222"/>
           </a:xfrm>
         </p:spPr>
         <p:txBody>
@@ -1762,19 +1605,13 @@
               <a:rPr lang="de-DE"/>
               <a:t>Fünfte Ebene</a:t>
             </a:r>
-            <a:endParaRPr lang="de-AT"/>
-          </a:p>
-        </p:txBody>
-      </p:sp>
-      <p:sp>
-        <p:nvSpPr>
-          <p:cNvPr id="4" name="Inhaltsplatzhalter 3">
-            <a:extLst>
-              <a:ext uri="{FF2B5EF4-FFF2-40B4-BE49-F238E27FC236}">
-                <a16:creationId xmlns:a16="http://schemas.microsoft.com/office/drawing/2014/main" id="{5C45F3AA-759A-DE50-2F1F-F718EE1DC80B}"/>
-              </a:ext>
-            </a:extLst>
-          </p:cNvPr>
+            <a:endParaRPr lang="en-US" dirty="0"/>
+          </a:p>
+        </p:txBody>
+      </p:sp>
+      <p:sp>
+        <p:nvSpPr>
+          <p:cNvPr id="4" name="Content Placeholder 3"/>
           <p:cNvSpPr>
             <a:spLocks noGrp="1"/>
           </p:cNvSpPr>
@@ -1784,8 +1621,8 @@
         </p:nvSpPr>
         <p:spPr>
           <a:xfrm>
-            <a:off x="6172200" y="1825625"/>
-            <a:ext cx="5181600" cy="4351338"/>
+            <a:off x="3980587" y="1818863"/>
+            <a:ext cx="3341727" cy="4335222"/>
           </a:xfrm>
         </p:spPr>
         <p:txBody>
@@ -1825,19 +1662,13 @@
               <a:rPr lang="de-DE"/>
               <a:t>Fünfte Ebene</a:t>
             </a:r>
-            <a:endParaRPr lang="de-AT"/>
-          </a:p>
-        </p:txBody>
-      </p:sp>
-      <p:sp>
-        <p:nvSpPr>
-          <p:cNvPr id="5" name="Datumsplatzhalter 4">
-            <a:extLst>
-              <a:ext uri="{FF2B5EF4-FFF2-40B4-BE49-F238E27FC236}">
-                <a16:creationId xmlns:a16="http://schemas.microsoft.com/office/drawing/2014/main" id="{87D32C55-7658-AB90-CCF8-6A92932D509C}"/>
-              </a:ext>
-            </a:extLst>
-          </p:cNvPr>
+            <a:endParaRPr lang="en-US" dirty="0"/>
+          </a:p>
+        </p:txBody>
+      </p:sp>
+      <p:sp>
+        <p:nvSpPr>
+          <p:cNvPr id="5" name="Date Placeholder 4"/>
           <p:cNvSpPr>
             <a:spLocks noGrp="1"/>
           </p:cNvSpPr>
@@ -1852,7 +1683,7 @@
           <a:p>
             <a:fld id="{0E4C2A6E-34C0-4481-B3D7-04230C49192B}" type="datetimeFigureOut">
               <a:rPr lang="de-AT" smtClean="0"/>
-              <a:t>20.02.2026</a:t>
+              <a:t>21.02.2026</a:t>
             </a:fld>
             <a:endParaRPr lang="de-AT"/>
           </a:p>
@@ -1860,13 +1691,7 @@
       </p:sp>
       <p:sp>
         <p:nvSpPr>
-          <p:cNvPr id="6" name="Fußzeilenplatzhalter 5">
-            <a:extLst>
-              <a:ext uri="{FF2B5EF4-FFF2-40B4-BE49-F238E27FC236}">
-                <a16:creationId xmlns:a16="http://schemas.microsoft.com/office/drawing/2014/main" id="{58AE371A-2BCA-D79E-926B-DD7E80D060C6}"/>
-              </a:ext>
-            </a:extLst>
-          </p:cNvPr>
+          <p:cNvPr id="6" name="Footer Placeholder 5"/>
           <p:cNvSpPr>
             <a:spLocks noGrp="1"/>
           </p:cNvSpPr>
@@ -1885,13 +1710,7 @@
       </p:sp>
       <p:sp>
         <p:nvSpPr>
-          <p:cNvPr id="7" name="Foliennummernplatzhalter 6">
-            <a:extLst>
-              <a:ext uri="{FF2B5EF4-FFF2-40B4-BE49-F238E27FC236}">
-                <a16:creationId xmlns:a16="http://schemas.microsoft.com/office/drawing/2014/main" id="{983B863C-8DE1-5D7D-5B6D-F2DD428455EC}"/>
-              </a:ext>
-            </a:extLst>
-          </p:cNvPr>
+          <p:cNvPr id="7" name="Slide Number Placeholder 6"/>
           <p:cNvSpPr>
             <a:spLocks noGrp="1"/>
           </p:cNvSpPr>
@@ -1915,7 +1734,7 @@
     </p:spTree>
     <p:extLst>
       <p:ext uri="{BB962C8B-B14F-4D97-AF65-F5344CB8AC3E}">
-        <p14:creationId xmlns:p14="http://schemas.microsoft.com/office/powerpoint/2010/main" val="3852843736"/>
+        <p14:creationId xmlns:p14="http://schemas.microsoft.com/office/powerpoint/2010/main" val="4013623410"/>
       </p:ext>
     </p:extLst>
   </p:cSld>
@@ -1944,13 +1763,7 @@
       </p:grpSpPr>
       <p:sp>
         <p:nvSpPr>
-          <p:cNvPr id="2" name="Titel 1">
-            <a:extLst>
-              <a:ext uri="{FF2B5EF4-FFF2-40B4-BE49-F238E27FC236}">
-                <a16:creationId xmlns:a16="http://schemas.microsoft.com/office/drawing/2014/main" id="{3DEDBBA6-1E05-7BBE-FA59-3451EF0A1012}"/>
-              </a:ext>
-            </a:extLst>
-          </p:cNvPr>
+          <p:cNvPr id="2" name="Title 1"/>
           <p:cNvSpPr>
             <a:spLocks noGrp="1"/>
           </p:cNvSpPr>
@@ -1960,8 +1773,8 @@
         </p:nvSpPr>
         <p:spPr>
           <a:xfrm>
-            <a:off x="839788" y="365125"/>
-            <a:ext cx="10515600" cy="1325563"/>
+            <a:off x="541598" y="363774"/>
+            <a:ext cx="6781741" cy="1320654"/>
           </a:xfrm>
         </p:spPr>
         <p:txBody>
@@ -1972,19 +1785,13 @@
               <a:rPr lang="de-DE"/>
               <a:t>Mastertitelformat bearbeiten</a:t>
             </a:r>
-            <a:endParaRPr lang="de-AT"/>
-          </a:p>
-        </p:txBody>
-      </p:sp>
-      <p:sp>
-        <p:nvSpPr>
-          <p:cNvPr id="3" name="Textplatzhalter 2">
-            <a:extLst>
-              <a:ext uri="{FF2B5EF4-FFF2-40B4-BE49-F238E27FC236}">
-                <a16:creationId xmlns:a16="http://schemas.microsoft.com/office/drawing/2014/main" id="{60FE8E9C-D788-D296-80A6-1B5919A96EEF}"/>
-              </a:ext>
-            </a:extLst>
-          </p:cNvPr>
+            <a:endParaRPr lang="en-US" dirty="0"/>
+          </a:p>
+        </p:txBody>
+      </p:sp>
+      <p:sp>
+        <p:nvSpPr>
+          <p:cNvPr id="3" name="Text Placeholder 2"/>
           <p:cNvSpPr>
             <a:spLocks noGrp="1"/>
           </p:cNvSpPr>
@@ -1994,8 +1801,8 @@
         </p:nvSpPr>
         <p:spPr>
           <a:xfrm>
-            <a:off x="839788" y="1681163"/>
-            <a:ext cx="5157787" cy="823912"/>
+            <a:off x="541598" y="1674937"/>
+            <a:ext cx="3326370" cy="820860"/>
           </a:xfrm>
         </p:spPr>
         <p:txBody>
@@ -2003,39 +1810,39 @@
           <a:lstStyle>
             <a:lvl1pPr marL="0" indent="0">
               <a:buNone/>
-              <a:defRPr sz="2400" b="1"/>
+              <a:defRPr sz="2064" b="1"/>
             </a:lvl1pPr>
-            <a:lvl2pPr marL="457200" indent="0">
-              <a:buNone/>
-              <a:defRPr sz="2000" b="1"/>
+            <a:lvl2pPr marL="393146" indent="0">
+              <a:buNone/>
+              <a:defRPr sz="1720" b="1"/>
             </a:lvl2pPr>
-            <a:lvl3pPr marL="914400" indent="0">
-              <a:buNone/>
-              <a:defRPr sz="1800" b="1"/>
+            <a:lvl3pPr marL="786293" indent="0">
+              <a:buNone/>
+              <a:defRPr sz="1548" b="1"/>
             </a:lvl3pPr>
-            <a:lvl4pPr marL="1371600" indent="0">
-              <a:buNone/>
-              <a:defRPr sz="1600" b="1"/>
+            <a:lvl4pPr marL="1179439" indent="0">
+              <a:buNone/>
+              <a:defRPr sz="1376" b="1"/>
             </a:lvl4pPr>
-            <a:lvl5pPr marL="1828800" indent="0">
-              <a:buNone/>
-              <a:defRPr sz="1600" b="1"/>
+            <a:lvl5pPr marL="1572585" indent="0">
+              <a:buNone/>
+              <a:defRPr sz="1376" b="1"/>
             </a:lvl5pPr>
-            <a:lvl6pPr marL="2286000" indent="0">
-              <a:buNone/>
-              <a:defRPr sz="1600" b="1"/>
+            <a:lvl6pPr marL="1965731" indent="0">
+              <a:buNone/>
+              <a:defRPr sz="1376" b="1"/>
             </a:lvl6pPr>
-            <a:lvl7pPr marL="2743200" indent="0">
-              <a:buNone/>
-              <a:defRPr sz="1600" b="1"/>
+            <a:lvl7pPr marL="2358878" indent="0">
+              <a:buNone/>
+              <a:defRPr sz="1376" b="1"/>
             </a:lvl7pPr>
-            <a:lvl8pPr marL="3200400" indent="0">
-              <a:buNone/>
-              <a:defRPr sz="1600" b="1"/>
+            <a:lvl8pPr marL="2752024" indent="0">
+              <a:buNone/>
+              <a:defRPr sz="1376" b="1"/>
             </a:lvl8pPr>
-            <a:lvl9pPr marL="3657600" indent="0">
-              <a:buNone/>
-              <a:defRPr sz="1600" b="1"/>
+            <a:lvl9pPr marL="3145170" indent="0">
+              <a:buNone/>
+              <a:defRPr sz="1376" b="1"/>
             </a:lvl9pPr>
           </a:lstStyle>
           <a:p>
@@ -2049,13 +1856,7 @@
       </p:sp>
       <p:sp>
         <p:nvSpPr>
-          <p:cNvPr id="4" name="Inhaltsplatzhalter 3">
-            <a:extLst>
-              <a:ext uri="{FF2B5EF4-FFF2-40B4-BE49-F238E27FC236}">
-                <a16:creationId xmlns:a16="http://schemas.microsoft.com/office/drawing/2014/main" id="{E6418C35-4FD2-276B-78E2-C1690669C10C}"/>
-              </a:ext>
-            </a:extLst>
-          </p:cNvPr>
+          <p:cNvPr id="4" name="Content Placeholder 3"/>
           <p:cNvSpPr>
             <a:spLocks noGrp="1"/>
           </p:cNvSpPr>
@@ -2065,8 +1866,8 @@
         </p:nvSpPr>
         <p:spPr>
           <a:xfrm>
-            <a:off x="839788" y="2505075"/>
-            <a:ext cx="5157787" cy="3684588"/>
+            <a:off x="541598" y="2495797"/>
+            <a:ext cx="3326370" cy="3670941"/>
           </a:xfrm>
         </p:spPr>
         <p:txBody>
@@ -2106,19 +1907,13 @@
               <a:rPr lang="de-DE"/>
               <a:t>Fünfte Ebene</a:t>
             </a:r>
-            <a:endParaRPr lang="de-AT"/>
-          </a:p>
-        </p:txBody>
-      </p:sp>
-      <p:sp>
-        <p:nvSpPr>
-          <p:cNvPr id="5" name="Textplatzhalter 4">
-            <a:extLst>
-              <a:ext uri="{FF2B5EF4-FFF2-40B4-BE49-F238E27FC236}">
-                <a16:creationId xmlns:a16="http://schemas.microsoft.com/office/drawing/2014/main" id="{DFB7A036-98A5-CE04-85DF-1A5175E99BD6}"/>
-              </a:ext>
-            </a:extLst>
-          </p:cNvPr>
+            <a:endParaRPr lang="en-US" dirty="0"/>
+          </a:p>
+        </p:txBody>
+      </p:sp>
+      <p:sp>
+        <p:nvSpPr>
+          <p:cNvPr id="5" name="Text Placeholder 4"/>
           <p:cNvSpPr>
             <a:spLocks noGrp="1"/>
           </p:cNvSpPr>
@@ -2128,8 +1923,8 @@
         </p:nvSpPr>
         <p:spPr>
           <a:xfrm>
-            <a:off x="6172200" y="1681163"/>
-            <a:ext cx="5183188" cy="823912"/>
+            <a:off x="3980587" y="1674937"/>
+            <a:ext cx="3342752" cy="820860"/>
           </a:xfrm>
         </p:spPr>
         <p:txBody>
@@ -2137,39 +1932,39 @@
           <a:lstStyle>
             <a:lvl1pPr marL="0" indent="0">
               <a:buNone/>
-              <a:defRPr sz="2400" b="1"/>
+              <a:defRPr sz="2064" b="1"/>
             </a:lvl1pPr>
-            <a:lvl2pPr marL="457200" indent="0">
-              <a:buNone/>
-              <a:defRPr sz="2000" b="1"/>
+            <a:lvl2pPr marL="393146" indent="0">
+              <a:buNone/>
+              <a:defRPr sz="1720" b="1"/>
             </a:lvl2pPr>
-            <a:lvl3pPr marL="914400" indent="0">
-              <a:buNone/>
-              <a:defRPr sz="1800" b="1"/>
+            <a:lvl3pPr marL="786293" indent="0">
+              <a:buNone/>
+              <a:defRPr sz="1548" b="1"/>
             </a:lvl3pPr>
-            <a:lvl4pPr marL="1371600" indent="0">
-              <a:buNone/>
-              <a:defRPr sz="1600" b="1"/>
+            <a:lvl4pPr marL="1179439" indent="0">
+              <a:buNone/>
+              <a:defRPr sz="1376" b="1"/>
             </a:lvl4pPr>
-            <a:lvl5pPr marL="1828800" indent="0">
-              <a:buNone/>
-              <a:defRPr sz="1600" b="1"/>
+            <a:lvl5pPr marL="1572585" indent="0">
+              <a:buNone/>
+              <a:defRPr sz="1376" b="1"/>
             </a:lvl5pPr>
-            <a:lvl6pPr marL="2286000" indent="0">
-              <a:buNone/>
-              <a:defRPr sz="1600" b="1"/>
+            <a:lvl6pPr marL="1965731" indent="0">
+              <a:buNone/>
+              <a:defRPr sz="1376" b="1"/>
             </a:lvl6pPr>
-            <a:lvl7pPr marL="2743200" indent="0">
-              <a:buNone/>
-              <a:defRPr sz="1600" b="1"/>
+            <a:lvl7pPr marL="2358878" indent="0">
+              <a:buNone/>
+              <a:defRPr sz="1376" b="1"/>
             </a:lvl7pPr>
-            <a:lvl8pPr marL="3200400" indent="0">
-              <a:buNone/>
-              <a:defRPr sz="1600" b="1"/>
+            <a:lvl8pPr marL="2752024" indent="0">
+              <a:buNone/>
+              <a:defRPr sz="1376" b="1"/>
             </a:lvl8pPr>
-            <a:lvl9pPr marL="3657600" indent="0">
-              <a:buNone/>
-              <a:defRPr sz="1600" b="1"/>
+            <a:lvl9pPr marL="3145170" indent="0">
+              <a:buNone/>
+              <a:defRPr sz="1376" b="1"/>
             </a:lvl9pPr>
           </a:lstStyle>
           <a:p>
@@ -2183,13 +1978,7 @@
       </p:sp>
       <p:sp>
         <p:nvSpPr>
-          <p:cNvPr id="6" name="Inhaltsplatzhalter 5">
-            <a:extLst>
-              <a:ext uri="{FF2B5EF4-FFF2-40B4-BE49-F238E27FC236}">
-                <a16:creationId xmlns:a16="http://schemas.microsoft.com/office/drawing/2014/main" id="{9A673CDD-BC06-3548-C4DD-90670B2EBA8B}"/>
-              </a:ext>
-            </a:extLst>
-          </p:cNvPr>
+          <p:cNvPr id="6" name="Content Placeholder 5"/>
           <p:cNvSpPr>
             <a:spLocks noGrp="1"/>
           </p:cNvSpPr>
@@ -2199,8 +1988,8 @@
         </p:nvSpPr>
         <p:spPr>
           <a:xfrm>
-            <a:off x="6172200" y="2505075"/>
-            <a:ext cx="5183188" cy="3684588"/>
+            <a:off x="3980587" y="2495797"/>
+            <a:ext cx="3342752" cy="3670941"/>
           </a:xfrm>
         </p:spPr>
         <p:txBody>
@@ -2240,19 +2029,13 @@
               <a:rPr lang="de-DE"/>
               <a:t>Fünfte Ebene</a:t>
             </a:r>
-            <a:endParaRPr lang="de-AT"/>
-          </a:p>
-        </p:txBody>
-      </p:sp>
-      <p:sp>
-        <p:nvSpPr>
-          <p:cNvPr id="7" name="Datumsplatzhalter 6">
-            <a:extLst>
-              <a:ext uri="{FF2B5EF4-FFF2-40B4-BE49-F238E27FC236}">
-                <a16:creationId xmlns:a16="http://schemas.microsoft.com/office/drawing/2014/main" id="{6DCE3F4E-D58C-727A-1D5B-F3FE6A781B37}"/>
-              </a:ext>
-            </a:extLst>
-          </p:cNvPr>
+            <a:endParaRPr lang="en-US" dirty="0"/>
+          </a:p>
+        </p:txBody>
+      </p:sp>
+      <p:sp>
+        <p:nvSpPr>
+          <p:cNvPr id="7" name="Date Placeholder 6"/>
           <p:cNvSpPr>
             <a:spLocks noGrp="1"/>
           </p:cNvSpPr>
@@ -2267,7 +2050,7 @@
           <a:p>
             <a:fld id="{0E4C2A6E-34C0-4481-B3D7-04230C49192B}" type="datetimeFigureOut">
               <a:rPr lang="de-AT" smtClean="0"/>
-              <a:t>20.02.2026</a:t>
+              <a:t>21.02.2026</a:t>
             </a:fld>
             <a:endParaRPr lang="de-AT"/>
           </a:p>
@@ -2275,13 +2058,7 @@
       </p:sp>
       <p:sp>
         <p:nvSpPr>
-          <p:cNvPr id="8" name="Fußzeilenplatzhalter 7">
-            <a:extLst>
-              <a:ext uri="{FF2B5EF4-FFF2-40B4-BE49-F238E27FC236}">
-                <a16:creationId xmlns:a16="http://schemas.microsoft.com/office/drawing/2014/main" id="{6D423DB9-D83C-17FE-B549-4437E78FE828}"/>
-              </a:ext>
-            </a:extLst>
-          </p:cNvPr>
+          <p:cNvPr id="8" name="Footer Placeholder 7"/>
           <p:cNvSpPr>
             <a:spLocks noGrp="1"/>
           </p:cNvSpPr>
@@ -2300,13 +2077,7 @@
       </p:sp>
       <p:sp>
         <p:nvSpPr>
-          <p:cNvPr id="9" name="Foliennummernplatzhalter 8">
-            <a:extLst>
-              <a:ext uri="{FF2B5EF4-FFF2-40B4-BE49-F238E27FC236}">
-                <a16:creationId xmlns:a16="http://schemas.microsoft.com/office/drawing/2014/main" id="{E3DEB2FD-18AA-11C9-51AE-10AFDA555188}"/>
-              </a:ext>
-            </a:extLst>
-          </p:cNvPr>
+          <p:cNvPr id="9" name="Slide Number Placeholder 8"/>
           <p:cNvSpPr>
             <a:spLocks noGrp="1"/>
           </p:cNvSpPr>
@@ -2330,7 +2101,7 @@
     </p:spTree>
     <p:extLst>
       <p:ext uri="{BB962C8B-B14F-4D97-AF65-F5344CB8AC3E}">
-        <p14:creationId xmlns:p14="http://schemas.microsoft.com/office/powerpoint/2010/main" val="3240586740"/>
+        <p14:creationId xmlns:p14="http://schemas.microsoft.com/office/powerpoint/2010/main" val="1808902309"/>
       </p:ext>
     </p:extLst>
   </p:cSld>
@@ -2359,13 +2130,7 @@
       </p:grpSpPr>
       <p:sp>
         <p:nvSpPr>
-          <p:cNvPr id="2" name="Titel 1">
-            <a:extLst>
-              <a:ext uri="{FF2B5EF4-FFF2-40B4-BE49-F238E27FC236}">
-                <a16:creationId xmlns:a16="http://schemas.microsoft.com/office/drawing/2014/main" id="{7BD139C7-0C9B-D9C4-F01D-EE8C4C5F0779}"/>
-              </a:ext>
-            </a:extLst>
-          </p:cNvPr>
+          <p:cNvPr id="2" name="Title 1"/>
           <p:cNvSpPr>
             <a:spLocks noGrp="1"/>
           </p:cNvSpPr>
@@ -2382,19 +2147,13 @@
               <a:rPr lang="de-DE"/>
               <a:t>Mastertitelformat bearbeiten</a:t>
             </a:r>
-            <a:endParaRPr lang="de-AT"/>
-          </a:p>
-        </p:txBody>
-      </p:sp>
-      <p:sp>
-        <p:nvSpPr>
-          <p:cNvPr id="3" name="Datumsplatzhalter 2">
-            <a:extLst>
-              <a:ext uri="{FF2B5EF4-FFF2-40B4-BE49-F238E27FC236}">
-                <a16:creationId xmlns:a16="http://schemas.microsoft.com/office/drawing/2014/main" id="{2157FD1A-B8BA-667A-BD12-2A97FD225949}"/>
-              </a:ext>
-            </a:extLst>
-          </p:cNvPr>
+            <a:endParaRPr lang="en-US" dirty="0"/>
+          </a:p>
+        </p:txBody>
+      </p:sp>
+      <p:sp>
+        <p:nvSpPr>
+          <p:cNvPr id="3" name="Date Placeholder 2"/>
           <p:cNvSpPr>
             <a:spLocks noGrp="1"/>
           </p:cNvSpPr>
@@ -2409,7 +2168,7 @@
           <a:p>
             <a:fld id="{0E4C2A6E-34C0-4481-B3D7-04230C49192B}" type="datetimeFigureOut">
               <a:rPr lang="de-AT" smtClean="0"/>
-              <a:t>20.02.2026</a:t>
+              <a:t>21.02.2026</a:t>
             </a:fld>
             <a:endParaRPr lang="de-AT"/>
           </a:p>
@@ -2417,13 +2176,7 @@
       </p:sp>
       <p:sp>
         <p:nvSpPr>
-          <p:cNvPr id="4" name="Fußzeilenplatzhalter 3">
-            <a:extLst>
-              <a:ext uri="{FF2B5EF4-FFF2-40B4-BE49-F238E27FC236}">
-                <a16:creationId xmlns:a16="http://schemas.microsoft.com/office/drawing/2014/main" id="{0CCF175B-2117-EFBF-DAA3-33F1DEA2F028}"/>
-              </a:ext>
-            </a:extLst>
-          </p:cNvPr>
+          <p:cNvPr id="4" name="Footer Placeholder 3"/>
           <p:cNvSpPr>
             <a:spLocks noGrp="1"/>
           </p:cNvSpPr>
@@ -2442,13 +2195,7 @@
       </p:sp>
       <p:sp>
         <p:nvSpPr>
-          <p:cNvPr id="5" name="Foliennummernplatzhalter 4">
-            <a:extLst>
-              <a:ext uri="{FF2B5EF4-FFF2-40B4-BE49-F238E27FC236}">
-                <a16:creationId xmlns:a16="http://schemas.microsoft.com/office/drawing/2014/main" id="{00C6C972-4FB9-AD18-F442-CC6104D97ABF}"/>
-              </a:ext>
-            </a:extLst>
-          </p:cNvPr>
+          <p:cNvPr id="5" name="Slide Number Placeholder 4"/>
           <p:cNvSpPr>
             <a:spLocks noGrp="1"/>
           </p:cNvSpPr>
@@ -2472,7 +2219,7 @@
     </p:spTree>
     <p:extLst>
       <p:ext uri="{BB962C8B-B14F-4D97-AF65-F5344CB8AC3E}">
-        <p14:creationId xmlns:p14="http://schemas.microsoft.com/office/powerpoint/2010/main" val="996411461"/>
+        <p14:creationId xmlns:p14="http://schemas.microsoft.com/office/powerpoint/2010/main" val="2605165820"/>
       </p:ext>
     </p:extLst>
   </p:cSld>
@@ -2501,13 +2248,7 @@
       </p:grpSpPr>
       <p:sp>
         <p:nvSpPr>
-          <p:cNvPr id="2" name="Datumsplatzhalter 1">
-            <a:extLst>
-              <a:ext uri="{FF2B5EF4-FFF2-40B4-BE49-F238E27FC236}">
-                <a16:creationId xmlns:a16="http://schemas.microsoft.com/office/drawing/2014/main" id="{BDF12404-9403-922C-A784-99A756D4BF9A}"/>
-              </a:ext>
-            </a:extLst>
-          </p:cNvPr>
+          <p:cNvPr id="2" name="Date Placeholder 1"/>
           <p:cNvSpPr>
             <a:spLocks noGrp="1"/>
           </p:cNvSpPr>
@@ -2522,7 +2263,7 @@
           <a:p>
             <a:fld id="{0E4C2A6E-34C0-4481-B3D7-04230C49192B}" type="datetimeFigureOut">
               <a:rPr lang="de-AT" smtClean="0"/>
-              <a:t>20.02.2026</a:t>
+              <a:t>21.02.2026</a:t>
             </a:fld>
             <a:endParaRPr lang="de-AT"/>
           </a:p>
@@ -2530,13 +2271,7 @@
       </p:sp>
       <p:sp>
         <p:nvSpPr>
-          <p:cNvPr id="3" name="Fußzeilenplatzhalter 2">
-            <a:extLst>
-              <a:ext uri="{FF2B5EF4-FFF2-40B4-BE49-F238E27FC236}">
-                <a16:creationId xmlns:a16="http://schemas.microsoft.com/office/drawing/2014/main" id="{0FB2C5E9-1307-3CAF-109F-E8436452AA38}"/>
-              </a:ext>
-            </a:extLst>
-          </p:cNvPr>
+          <p:cNvPr id="3" name="Footer Placeholder 2"/>
           <p:cNvSpPr>
             <a:spLocks noGrp="1"/>
           </p:cNvSpPr>
@@ -2555,13 +2290,7 @@
       </p:sp>
       <p:sp>
         <p:nvSpPr>
-          <p:cNvPr id="4" name="Foliennummernplatzhalter 3">
-            <a:extLst>
-              <a:ext uri="{FF2B5EF4-FFF2-40B4-BE49-F238E27FC236}">
-                <a16:creationId xmlns:a16="http://schemas.microsoft.com/office/drawing/2014/main" id="{03FDB9DD-7AE6-3D4C-1D51-FF828E58E5AE}"/>
-              </a:ext>
-            </a:extLst>
-          </p:cNvPr>
+          <p:cNvPr id="4" name="Slide Number Placeholder 3"/>
           <p:cNvSpPr>
             <a:spLocks noGrp="1"/>
           </p:cNvSpPr>
@@ -2585,7 +2314,7 @@
     </p:spTree>
     <p:extLst>
       <p:ext uri="{BB962C8B-B14F-4D97-AF65-F5344CB8AC3E}">
-        <p14:creationId xmlns:p14="http://schemas.microsoft.com/office/powerpoint/2010/main" val="3200579534"/>
+        <p14:creationId xmlns:p14="http://schemas.microsoft.com/office/powerpoint/2010/main" val="4264622278"/>
       </p:ext>
     </p:extLst>
   </p:cSld>
@@ -2614,13 +2343,7 @@
       </p:grpSpPr>
       <p:sp>
         <p:nvSpPr>
-          <p:cNvPr id="2" name="Titel 1">
-            <a:extLst>
-              <a:ext uri="{FF2B5EF4-FFF2-40B4-BE49-F238E27FC236}">
-                <a16:creationId xmlns:a16="http://schemas.microsoft.com/office/drawing/2014/main" id="{65A4E22C-58B8-363F-E5CE-AD86BBA0EAA1}"/>
-              </a:ext>
-            </a:extLst>
-          </p:cNvPr>
+          <p:cNvPr id="2" name="Title 1"/>
           <p:cNvSpPr>
             <a:spLocks noGrp="1"/>
           </p:cNvSpPr>
@@ -2630,15 +2353,15 @@
         </p:nvSpPr>
         <p:spPr>
           <a:xfrm>
-            <a:off x="839788" y="457200"/>
-            <a:ext cx="3932237" cy="1600200"/>
+            <a:off x="541598" y="455507"/>
+            <a:ext cx="2535986" cy="1594273"/>
           </a:xfrm>
         </p:spPr>
         <p:txBody>
           <a:bodyPr anchor="b"/>
           <a:lstStyle>
             <a:lvl1pPr>
-              <a:defRPr sz="3200"/>
+              <a:defRPr sz="2752"/>
             </a:lvl1pPr>
           </a:lstStyle>
           <a:p>
@@ -2646,19 +2369,13 @@
               <a:rPr lang="de-DE"/>
               <a:t>Mastertitelformat bearbeiten</a:t>
             </a:r>
-            <a:endParaRPr lang="de-AT"/>
-          </a:p>
-        </p:txBody>
-      </p:sp>
-      <p:sp>
-        <p:nvSpPr>
-          <p:cNvPr id="3" name="Inhaltsplatzhalter 2">
-            <a:extLst>
-              <a:ext uri="{FF2B5EF4-FFF2-40B4-BE49-F238E27FC236}">
-                <a16:creationId xmlns:a16="http://schemas.microsoft.com/office/drawing/2014/main" id="{F5217904-525B-A821-EE89-B9B05F56D6CA}"/>
-              </a:ext>
-            </a:extLst>
-          </p:cNvPr>
+            <a:endParaRPr lang="en-US" dirty="0"/>
+          </a:p>
+        </p:txBody>
+      </p:sp>
+      <p:sp>
+        <p:nvSpPr>
+          <p:cNvPr id="3" name="Content Placeholder 2"/>
           <p:cNvSpPr>
             <a:spLocks noGrp="1"/>
           </p:cNvSpPr>
@@ -2668,39 +2385,39 @@
         </p:nvSpPr>
         <p:spPr>
           <a:xfrm>
-            <a:off x="5183188" y="987425"/>
-            <a:ext cx="6172200" cy="4873625"/>
+            <a:off x="3342752" y="983769"/>
+            <a:ext cx="3980587" cy="4855575"/>
           </a:xfrm>
         </p:spPr>
         <p:txBody>
           <a:bodyPr/>
           <a:lstStyle>
             <a:lvl1pPr>
-              <a:defRPr sz="3200"/>
+              <a:defRPr sz="2752"/>
             </a:lvl1pPr>
             <a:lvl2pPr>
-              <a:defRPr sz="2800"/>
+              <a:defRPr sz="2408"/>
             </a:lvl2pPr>
             <a:lvl3pPr>
-              <a:defRPr sz="2400"/>
+              <a:defRPr sz="2064"/>
             </a:lvl3pPr>
             <a:lvl4pPr>
-              <a:defRPr sz="2000"/>
+              <a:defRPr sz="1720"/>
             </a:lvl4pPr>
             <a:lvl5pPr>
-              <a:defRPr sz="2000"/>
+              <a:defRPr sz="1720"/>
             </a:lvl5pPr>
             <a:lvl6pPr>
-              <a:defRPr sz="2000"/>
+              <a:defRPr sz="1720"/>
             </a:lvl6pPr>
             <a:lvl7pPr>
-              <a:defRPr sz="2000"/>
+              <a:defRPr sz="1720"/>
             </a:lvl7pPr>
             <a:lvl8pPr>
-              <a:defRPr sz="2000"/>
+              <a:defRPr sz="1720"/>
             </a:lvl8pPr>
             <a:lvl9pPr>
-              <a:defRPr sz="2000"/>
+              <a:defRPr sz="1720"/>
             </a:lvl9pPr>
           </a:lstStyle>
           <a:p>
@@ -2737,19 +2454,13 @@
               <a:rPr lang="de-DE"/>
               <a:t>Fünfte Ebene</a:t>
             </a:r>
-            <a:endParaRPr lang="de-AT"/>
-          </a:p>
-        </p:txBody>
-      </p:sp>
-      <p:sp>
-        <p:nvSpPr>
-          <p:cNvPr id="4" name="Textplatzhalter 3">
-            <a:extLst>
-              <a:ext uri="{FF2B5EF4-FFF2-40B4-BE49-F238E27FC236}">
-                <a16:creationId xmlns:a16="http://schemas.microsoft.com/office/drawing/2014/main" id="{B6ACAE6E-F20F-AF63-5256-6BC00165FDD7}"/>
-              </a:ext>
-            </a:extLst>
-          </p:cNvPr>
+            <a:endParaRPr lang="en-US" dirty="0"/>
+          </a:p>
+        </p:txBody>
+      </p:sp>
+      <p:sp>
+        <p:nvSpPr>
+          <p:cNvPr id="4" name="Text Placeholder 3"/>
           <p:cNvSpPr>
             <a:spLocks noGrp="1"/>
           </p:cNvSpPr>
@@ -2759,8 +2470,8 @@
         </p:nvSpPr>
         <p:spPr>
           <a:xfrm>
-            <a:off x="839788" y="2057400"/>
-            <a:ext cx="3932237" cy="3811588"/>
+            <a:off x="541598" y="2049780"/>
+            <a:ext cx="2535986" cy="3797471"/>
           </a:xfrm>
         </p:spPr>
         <p:txBody>
@@ -2768,39 +2479,39 @@
           <a:lstStyle>
             <a:lvl1pPr marL="0" indent="0">
               <a:buNone/>
-              <a:defRPr sz="1600"/>
+              <a:defRPr sz="1376"/>
             </a:lvl1pPr>
-            <a:lvl2pPr marL="457200" indent="0">
-              <a:buNone/>
-              <a:defRPr sz="1400"/>
+            <a:lvl2pPr marL="393146" indent="0">
+              <a:buNone/>
+              <a:defRPr sz="1204"/>
             </a:lvl2pPr>
-            <a:lvl3pPr marL="914400" indent="0">
-              <a:buNone/>
-              <a:defRPr sz="1200"/>
+            <a:lvl3pPr marL="786293" indent="0">
+              <a:buNone/>
+              <a:defRPr sz="1032"/>
             </a:lvl3pPr>
-            <a:lvl4pPr marL="1371600" indent="0">
-              <a:buNone/>
-              <a:defRPr sz="1000"/>
+            <a:lvl4pPr marL="1179439" indent="0">
+              <a:buNone/>
+              <a:defRPr sz="860"/>
             </a:lvl4pPr>
-            <a:lvl5pPr marL="1828800" indent="0">
-              <a:buNone/>
-              <a:defRPr sz="1000"/>
+            <a:lvl5pPr marL="1572585" indent="0">
+              <a:buNone/>
+              <a:defRPr sz="860"/>
             </a:lvl5pPr>
-            <a:lvl6pPr marL="2286000" indent="0">
-              <a:buNone/>
-              <a:defRPr sz="1000"/>
+            <a:lvl6pPr marL="1965731" indent="0">
+              <a:buNone/>
+              <a:defRPr sz="860"/>
             </a:lvl6pPr>
-            <a:lvl7pPr marL="2743200" indent="0">
-              <a:buNone/>
-              <a:defRPr sz="1000"/>
+            <a:lvl7pPr marL="2358878" indent="0">
+              <a:buNone/>
+              <a:defRPr sz="860"/>
             </a:lvl7pPr>
-            <a:lvl8pPr marL="3200400" indent="0">
-              <a:buNone/>
-              <a:defRPr sz="1000"/>
+            <a:lvl8pPr marL="2752024" indent="0">
+              <a:buNone/>
+              <a:defRPr sz="860"/>
             </a:lvl8pPr>
-            <a:lvl9pPr marL="3657600" indent="0">
-              <a:buNone/>
-              <a:defRPr sz="1000"/>
+            <a:lvl9pPr marL="3145170" indent="0">
+              <a:buNone/>
+              <a:defRPr sz="860"/>
             </a:lvl9pPr>
           </a:lstStyle>
           <a:p>
@@ -2814,13 +2525,7 @@
       </p:sp>
       <p:sp>
         <p:nvSpPr>
-          <p:cNvPr id="5" name="Datumsplatzhalter 4">
-            <a:extLst>
-              <a:ext uri="{FF2B5EF4-FFF2-40B4-BE49-F238E27FC236}">
-                <a16:creationId xmlns:a16="http://schemas.microsoft.com/office/drawing/2014/main" id="{BAB8214D-3468-39C2-EEA7-259FFEBAB4E4}"/>
-              </a:ext>
-            </a:extLst>
-          </p:cNvPr>
+          <p:cNvPr id="5" name="Date Placeholder 4"/>
           <p:cNvSpPr>
             <a:spLocks noGrp="1"/>
           </p:cNvSpPr>
@@ -2835,7 +2540,7 @@
           <a:p>
             <a:fld id="{0E4C2A6E-34C0-4481-B3D7-04230C49192B}" type="datetimeFigureOut">
               <a:rPr lang="de-AT" smtClean="0"/>
-              <a:t>20.02.2026</a:t>
+              <a:t>21.02.2026</a:t>
             </a:fld>
             <a:endParaRPr lang="de-AT"/>
           </a:p>
@@ -2843,13 +2548,7 @@
       </p:sp>
       <p:sp>
         <p:nvSpPr>
-          <p:cNvPr id="6" name="Fußzeilenplatzhalter 5">
-            <a:extLst>
-              <a:ext uri="{FF2B5EF4-FFF2-40B4-BE49-F238E27FC236}">
-                <a16:creationId xmlns:a16="http://schemas.microsoft.com/office/drawing/2014/main" id="{36BDD81B-9C0C-C23D-C889-1552768D4772}"/>
-              </a:ext>
-            </a:extLst>
-          </p:cNvPr>
+          <p:cNvPr id="6" name="Footer Placeholder 5"/>
           <p:cNvSpPr>
             <a:spLocks noGrp="1"/>
           </p:cNvSpPr>
@@ -2868,13 +2567,7 @@
       </p:sp>
       <p:sp>
         <p:nvSpPr>
-          <p:cNvPr id="7" name="Foliennummernplatzhalter 6">
-            <a:extLst>
-              <a:ext uri="{FF2B5EF4-FFF2-40B4-BE49-F238E27FC236}">
-                <a16:creationId xmlns:a16="http://schemas.microsoft.com/office/drawing/2014/main" id="{57C1F756-7920-5768-81F9-8AC8A0742663}"/>
-              </a:ext>
-            </a:extLst>
-          </p:cNvPr>
+          <p:cNvPr id="7" name="Slide Number Placeholder 6"/>
           <p:cNvSpPr>
             <a:spLocks noGrp="1"/>
           </p:cNvSpPr>
@@ -2898,7 +2591,7 @@
     </p:spTree>
     <p:extLst>
       <p:ext uri="{BB962C8B-B14F-4D97-AF65-F5344CB8AC3E}">
-        <p14:creationId xmlns:p14="http://schemas.microsoft.com/office/powerpoint/2010/main" val="2738654317"/>
+        <p14:creationId xmlns:p14="http://schemas.microsoft.com/office/powerpoint/2010/main" val="3503434094"/>
       </p:ext>
     </p:extLst>
   </p:cSld>
@@ -2927,13 +2620,7 @@
       </p:grpSpPr>
       <p:sp>
         <p:nvSpPr>
-          <p:cNvPr id="2" name="Titel 1">
-            <a:extLst>
-              <a:ext uri="{FF2B5EF4-FFF2-40B4-BE49-F238E27FC236}">
-                <a16:creationId xmlns:a16="http://schemas.microsoft.com/office/drawing/2014/main" id="{71AFE45A-83FE-F8CC-BAC1-81F9ECD247DA}"/>
-              </a:ext>
-            </a:extLst>
-          </p:cNvPr>
+          <p:cNvPr id="2" name="Title 1"/>
           <p:cNvSpPr>
             <a:spLocks noGrp="1"/>
           </p:cNvSpPr>
@@ -2943,15 +2630,15 @@
         </p:nvSpPr>
         <p:spPr>
           <a:xfrm>
-            <a:off x="839788" y="457200"/>
-            <a:ext cx="3932237" cy="1600200"/>
+            <a:off x="541598" y="455507"/>
+            <a:ext cx="2535986" cy="1594273"/>
           </a:xfrm>
         </p:spPr>
         <p:txBody>
           <a:bodyPr anchor="b"/>
           <a:lstStyle>
             <a:lvl1pPr>
-              <a:defRPr sz="3200"/>
+              <a:defRPr sz="2752"/>
             </a:lvl1pPr>
           </a:lstStyle>
           <a:p>
@@ -2959,21 +2646,15 @@
               <a:rPr lang="de-DE"/>
               <a:t>Mastertitelformat bearbeiten</a:t>
             </a:r>
-            <a:endParaRPr lang="de-AT"/>
-          </a:p>
-        </p:txBody>
-      </p:sp>
-      <p:sp>
-        <p:nvSpPr>
-          <p:cNvPr id="3" name="Bildplatzhalter 2">
-            <a:extLst>
-              <a:ext uri="{FF2B5EF4-FFF2-40B4-BE49-F238E27FC236}">
-                <a16:creationId xmlns:a16="http://schemas.microsoft.com/office/drawing/2014/main" id="{77956800-592C-0133-694C-FBDB749199ED}"/>
-              </a:ext>
-            </a:extLst>
-          </p:cNvPr>
-          <p:cNvSpPr>
-            <a:spLocks noGrp="1"/>
+            <a:endParaRPr lang="en-US" dirty="0"/>
+          </a:p>
+        </p:txBody>
+      </p:sp>
+      <p:sp>
+        <p:nvSpPr>
+          <p:cNvPr id="3" name="Picture Placeholder 2"/>
+          <p:cNvSpPr>
+            <a:spLocks noGrp="1" noChangeAspect="1"/>
           </p:cNvSpPr>
           <p:nvPr>
             <p:ph type="pic" idx="1"/>
@@ -2981,8 +2662,73 @@
         </p:nvSpPr>
         <p:spPr>
           <a:xfrm>
-            <a:off x="5183188" y="987425"/>
-            <a:ext cx="6172200" cy="4873625"/>
+            <a:off x="3342752" y="983769"/>
+            <a:ext cx="3980587" cy="4855575"/>
+          </a:xfrm>
+        </p:spPr>
+        <p:txBody>
+          <a:bodyPr anchor="t"/>
+          <a:lstStyle>
+            <a:lvl1pPr marL="0" indent="0">
+              <a:buNone/>
+              <a:defRPr sz="2752"/>
+            </a:lvl1pPr>
+            <a:lvl2pPr marL="393146" indent="0">
+              <a:buNone/>
+              <a:defRPr sz="2408"/>
+            </a:lvl2pPr>
+            <a:lvl3pPr marL="786293" indent="0">
+              <a:buNone/>
+              <a:defRPr sz="2064"/>
+            </a:lvl3pPr>
+            <a:lvl4pPr marL="1179439" indent="0">
+              <a:buNone/>
+              <a:defRPr sz="1720"/>
+            </a:lvl4pPr>
+            <a:lvl5pPr marL="1572585" indent="0">
+              <a:buNone/>
+              <a:defRPr sz="1720"/>
+            </a:lvl5pPr>
+            <a:lvl6pPr marL="1965731" indent="0">
+              <a:buNone/>
+              <a:defRPr sz="1720"/>
+            </a:lvl6pPr>
+            <a:lvl7pPr marL="2358878" indent="0">
+              <a:buNone/>
+              <a:defRPr sz="1720"/>
+            </a:lvl7pPr>
+            <a:lvl8pPr marL="2752024" indent="0">
+              <a:buNone/>
+              <a:defRPr sz="1720"/>
+            </a:lvl8pPr>
+            <a:lvl9pPr marL="3145170" indent="0">
+              <a:buNone/>
+              <a:defRPr sz="1720"/>
+            </a:lvl9pPr>
+          </a:lstStyle>
+          <a:p>
+            <a:r>
+              <a:rPr lang="de-DE"/>
+              <a:t>Bild durch Klicken auf Symbol hinzufügen</a:t>
+            </a:r>
+            <a:endParaRPr lang="en-US" dirty="0"/>
+          </a:p>
+        </p:txBody>
+      </p:sp>
+      <p:sp>
+        <p:nvSpPr>
+          <p:cNvPr id="4" name="Text Placeholder 3"/>
+          <p:cNvSpPr>
+            <a:spLocks noGrp="1"/>
+          </p:cNvSpPr>
+          <p:nvPr>
+            <p:ph type="body" sz="half" idx="2"/>
+          </p:nvPr>
+        </p:nvSpPr>
+        <p:spPr>
+          <a:xfrm>
+            <a:off x="541598" y="2049780"/>
+            <a:ext cx="2535986" cy="3797471"/>
           </a:xfrm>
         </p:spPr>
         <p:txBody>
@@ -2990,109 +2736,42 @@
           <a:lstStyle>
             <a:lvl1pPr marL="0" indent="0">
               <a:buNone/>
-              <a:defRPr sz="3200"/>
+              <a:defRPr sz="1376"/>
             </a:lvl1pPr>
-            <a:lvl2pPr marL="457200" indent="0">
-              <a:buNone/>
-              <a:defRPr sz="2800"/>
+            <a:lvl2pPr marL="393146" indent="0">
+              <a:buNone/>
+              <a:defRPr sz="1204"/>
             </a:lvl2pPr>
-            <a:lvl3pPr marL="914400" indent="0">
-              <a:buNone/>
-              <a:defRPr sz="2400"/>
+            <a:lvl3pPr marL="786293" indent="0">
+              <a:buNone/>
+              <a:defRPr sz="1032"/>
             </a:lvl3pPr>
-            <a:lvl4pPr marL="1371600" indent="0">
-              <a:buNone/>
-              <a:defRPr sz="2000"/>
+            <a:lvl4pPr marL="1179439" indent="0">
+              <a:buNone/>
+              <a:defRPr sz="860"/>
             </a:lvl4pPr>
-            <a:lvl5pPr marL="1828800" indent="0">
-              <a:buNone/>
-              <a:defRPr sz="2000"/>
+            <a:lvl5pPr marL="1572585" indent="0">
+              <a:buNone/>
+              <a:defRPr sz="860"/>
             </a:lvl5pPr>
-            <a:lvl6pPr marL="2286000" indent="0">
-              <a:buNone/>
-              <a:defRPr sz="2000"/>
+            <a:lvl6pPr marL="1965731" indent="0">
+              <a:buNone/>
+              <a:defRPr sz="860"/>
             </a:lvl6pPr>
-            <a:lvl7pPr marL="2743200" indent="0">
-              <a:buNone/>
-              <a:defRPr sz="2000"/>
+            <a:lvl7pPr marL="2358878" indent="0">
+              <a:buNone/>
+              <a:defRPr sz="860"/>
             </a:lvl7pPr>
-            <a:lvl8pPr marL="3200400" indent="0">
-              <a:buNone/>
-              <a:defRPr sz="2000"/>
+            <a:lvl8pPr marL="2752024" indent="0">
+              <a:buNone/>
+              <a:defRPr sz="860"/>
             </a:lvl8pPr>
-            <a:lvl9pPr marL="3657600" indent="0">
-              <a:buNone/>
-              <a:defRPr sz="2000"/>
+            <a:lvl9pPr marL="3145170" indent="0">
+              <a:buNone/>
+              <a:defRPr sz="860"/>
             </a:lvl9pPr>
           </a:lstStyle>
           <a:p>
-            <a:endParaRPr lang="de-AT"/>
-          </a:p>
-        </p:txBody>
-      </p:sp>
-      <p:sp>
-        <p:nvSpPr>
-          <p:cNvPr id="4" name="Textplatzhalter 3">
-            <a:extLst>
-              <a:ext uri="{FF2B5EF4-FFF2-40B4-BE49-F238E27FC236}">
-                <a16:creationId xmlns:a16="http://schemas.microsoft.com/office/drawing/2014/main" id="{C8E5DCB5-3945-E0F6-AE14-51FF898B9D63}"/>
-              </a:ext>
-            </a:extLst>
-          </p:cNvPr>
-          <p:cNvSpPr>
-            <a:spLocks noGrp="1"/>
-          </p:cNvSpPr>
-          <p:nvPr>
-            <p:ph type="body" sz="half" idx="2"/>
-          </p:nvPr>
-        </p:nvSpPr>
-        <p:spPr>
-          <a:xfrm>
-            <a:off x="839788" y="2057400"/>
-            <a:ext cx="3932237" cy="3811588"/>
-          </a:xfrm>
-        </p:spPr>
-        <p:txBody>
-          <a:bodyPr/>
-          <a:lstStyle>
-            <a:lvl1pPr marL="0" indent="0">
-              <a:buNone/>
-              <a:defRPr sz="1600"/>
-            </a:lvl1pPr>
-            <a:lvl2pPr marL="457200" indent="0">
-              <a:buNone/>
-              <a:defRPr sz="1400"/>
-            </a:lvl2pPr>
-            <a:lvl3pPr marL="914400" indent="0">
-              <a:buNone/>
-              <a:defRPr sz="1200"/>
-            </a:lvl3pPr>
-            <a:lvl4pPr marL="1371600" indent="0">
-              <a:buNone/>
-              <a:defRPr sz="1000"/>
-            </a:lvl4pPr>
-            <a:lvl5pPr marL="1828800" indent="0">
-              <a:buNone/>
-              <a:defRPr sz="1000"/>
-            </a:lvl5pPr>
-            <a:lvl6pPr marL="2286000" indent="0">
-              <a:buNone/>
-              <a:defRPr sz="1000"/>
-            </a:lvl6pPr>
-            <a:lvl7pPr marL="2743200" indent="0">
-              <a:buNone/>
-              <a:defRPr sz="1000"/>
-            </a:lvl7pPr>
-            <a:lvl8pPr marL="3200400" indent="0">
-              <a:buNone/>
-              <a:defRPr sz="1000"/>
-            </a:lvl8pPr>
-            <a:lvl9pPr marL="3657600" indent="0">
-              <a:buNone/>
-              <a:defRPr sz="1000"/>
-            </a:lvl9pPr>
-          </a:lstStyle>
-          <a:p>
             <a:pPr lvl="0"/>
             <a:r>
               <a:rPr lang="de-DE"/>
@@ -3103,13 +2782,7 @@
       </p:sp>
       <p:sp>
         <p:nvSpPr>
-          <p:cNvPr id="5" name="Datumsplatzhalter 4">
-            <a:extLst>
-              <a:ext uri="{FF2B5EF4-FFF2-40B4-BE49-F238E27FC236}">
-                <a16:creationId xmlns:a16="http://schemas.microsoft.com/office/drawing/2014/main" id="{FB30A219-7539-75F4-3F8E-873DE20DD465}"/>
-              </a:ext>
-            </a:extLst>
-          </p:cNvPr>
+          <p:cNvPr id="5" name="Date Placeholder 4"/>
           <p:cNvSpPr>
             <a:spLocks noGrp="1"/>
           </p:cNvSpPr>
@@ -3124,7 +2797,7 @@
           <a:p>
             <a:fld id="{0E4C2A6E-34C0-4481-B3D7-04230C49192B}" type="datetimeFigureOut">
               <a:rPr lang="de-AT" smtClean="0"/>
-              <a:t>20.02.2026</a:t>
+              <a:t>21.02.2026</a:t>
             </a:fld>
             <a:endParaRPr lang="de-AT"/>
           </a:p>
@@ -3132,13 +2805,7 @@
       </p:sp>
       <p:sp>
         <p:nvSpPr>
-          <p:cNvPr id="6" name="Fußzeilenplatzhalter 5">
-            <a:extLst>
-              <a:ext uri="{FF2B5EF4-FFF2-40B4-BE49-F238E27FC236}">
-                <a16:creationId xmlns:a16="http://schemas.microsoft.com/office/drawing/2014/main" id="{9C5E8A6D-399E-69E4-8A19-56DA25CB670A}"/>
-              </a:ext>
-            </a:extLst>
-          </p:cNvPr>
+          <p:cNvPr id="6" name="Footer Placeholder 5"/>
           <p:cNvSpPr>
             <a:spLocks noGrp="1"/>
           </p:cNvSpPr>
@@ -3157,13 +2824,7 @@
       </p:sp>
       <p:sp>
         <p:nvSpPr>
-          <p:cNvPr id="7" name="Foliennummernplatzhalter 6">
-            <a:extLst>
-              <a:ext uri="{FF2B5EF4-FFF2-40B4-BE49-F238E27FC236}">
-                <a16:creationId xmlns:a16="http://schemas.microsoft.com/office/drawing/2014/main" id="{2051609F-C226-1420-0938-5E115BCBAA5E}"/>
-              </a:ext>
-            </a:extLst>
-          </p:cNvPr>
+          <p:cNvPr id="7" name="Slide Number Placeholder 6"/>
           <p:cNvSpPr>
             <a:spLocks noGrp="1"/>
           </p:cNvSpPr>
@@ -3187,7 +2848,7 @@
     </p:spTree>
     <p:extLst>
       <p:ext uri="{BB962C8B-B14F-4D97-AF65-F5344CB8AC3E}">
-        <p14:creationId xmlns:p14="http://schemas.microsoft.com/office/powerpoint/2010/main" val="1484107874"/>
+        <p14:creationId xmlns:p14="http://schemas.microsoft.com/office/powerpoint/2010/main" val="1907533223"/>
       </p:ext>
     </p:extLst>
   </p:cSld>
@@ -3221,13 +2882,7 @@
       </p:grpSpPr>
       <p:sp>
         <p:nvSpPr>
-          <p:cNvPr id="2" name="Titelplatzhalter 1">
-            <a:extLst>
-              <a:ext uri="{FF2B5EF4-FFF2-40B4-BE49-F238E27FC236}">
-                <a16:creationId xmlns:a16="http://schemas.microsoft.com/office/drawing/2014/main" id="{A51F3AD5-A8A3-2D54-5FA5-3A771777CBFD}"/>
-              </a:ext>
-            </a:extLst>
-          </p:cNvPr>
+          <p:cNvPr id="2" name="Title Placeholder 1"/>
           <p:cNvSpPr>
             <a:spLocks noGrp="1"/>
           </p:cNvSpPr>
@@ -3237,8 +2892,8 @@
         </p:nvSpPr>
         <p:spPr>
           <a:xfrm>
-            <a:off x="838200" y="365125"/>
-            <a:ext cx="10515600" cy="1325563"/>
+            <a:off x="540574" y="363774"/>
+            <a:ext cx="6781741" cy="1320654"/>
           </a:xfrm>
           <a:prstGeom prst="rect">
             <a:avLst/>
@@ -3254,19 +2909,13 @@
               <a:rPr lang="de-DE"/>
               <a:t>Mastertitelformat bearbeiten</a:t>
             </a:r>
-            <a:endParaRPr lang="de-AT"/>
-          </a:p>
-        </p:txBody>
-      </p:sp>
-      <p:sp>
-        <p:nvSpPr>
-          <p:cNvPr id="3" name="Textplatzhalter 2">
-            <a:extLst>
-              <a:ext uri="{FF2B5EF4-FFF2-40B4-BE49-F238E27FC236}">
-                <a16:creationId xmlns:a16="http://schemas.microsoft.com/office/drawing/2014/main" id="{20562B3E-D777-1625-EDC4-7FEBA9AE0CA2}"/>
-              </a:ext>
-            </a:extLst>
-          </p:cNvPr>
+            <a:endParaRPr lang="en-US" dirty="0"/>
+          </a:p>
+        </p:txBody>
+      </p:sp>
+      <p:sp>
+        <p:nvSpPr>
+          <p:cNvPr id="3" name="Text Placeholder 2"/>
           <p:cNvSpPr>
             <a:spLocks noGrp="1"/>
           </p:cNvSpPr>
@@ -3276,8 +2925,8 @@
         </p:nvSpPr>
         <p:spPr>
           <a:xfrm>
-            <a:off x="838200" y="1825625"/>
-            <a:ext cx="10515600" cy="4351338"/>
+            <a:off x="540574" y="1818863"/>
+            <a:ext cx="6781741" cy="4335222"/>
           </a:xfrm>
           <a:prstGeom prst="rect">
             <a:avLst/>
@@ -3322,19 +2971,13 @@
               <a:rPr lang="de-DE"/>
               <a:t>Fünfte Ebene</a:t>
             </a:r>
-            <a:endParaRPr lang="de-AT"/>
-          </a:p>
-        </p:txBody>
-      </p:sp>
-      <p:sp>
-        <p:nvSpPr>
-          <p:cNvPr id="4" name="Datumsplatzhalter 3">
-            <a:extLst>
-              <a:ext uri="{FF2B5EF4-FFF2-40B4-BE49-F238E27FC236}">
-                <a16:creationId xmlns:a16="http://schemas.microsoft.com/office/drawing/2014/main" id="{AAFE24B7-9445-26A3-EBB4-4B919F6C24DC}"/>
-              </a:ext>
-            </a:extLst>
-          </p:cNvPr>
+            <a:endParaRPr lang="en-US" dirty="0"/>
+          </a:p>
+        </p:txBody>
+      </p:sp>
+      <p:sp>
+        <p:nvSpPr>
+          <p:cNvPr id="4" name="Date Placeholder 3"/>
           <p:cNvSpPr>
             <a:spLocks noGrp="1"/>
           </p:cNvSpPr>
@@ -3344,8 +2987,8 @@
         </p:nvSpPr>
         <p:spPr>
           <a:xfrm>
-            <a:off x="838200" y="6356350"/>
-            <a:ext cx="2743200" cy="365125"/>
+            <a:off x="540573" y="6332809"/>
+            <a:ext cx="1769150" cy="363773"/>
           </a:xfrm>
           <a:prstGeom prst="rect">
             <a:avLst/>
@@ -3355,7 +2998,7 @@
           <a:bodyPr vert="horz" lIns="91440" tIns="45720" rIns="91440" bIns="45720" rtlCol="0" anchor="ctr"/>
           <a:lstStyle>
             <a:lvl1pPr algn="l">
-              <a:defRPr sz="1200">
+              <a:defRPr sz="1032">
                 <a:solidFill>
                   <a:schemeClr val="tx1">
                     <a:tint val="82000"/>
@@ -3367,7 +3010,7 @@
           <a:p>
             <a:fld id="{0E4C2A6E-34C0-4481-B3D7-04230C49192B}" type="datetimeFigureOut">
               <a:rPr lang="de-AT" smtClean="0"/>
-              <a:t>20.02.2026</a:t>
+              <a:t>21.02.2026</a:t>
             </a:fld>
             <a:endParaRPr lang="de-AT"/>
           </a:p>
@@ -3375,13 +3018,7 @@
       </p:sp>
       <p:sp>
         <p:nvSpPr>
-          <p:cNvPr id="5" name="Fußzeilenplatzhalter 4">
-            <a:extLst>
-              <a:ext uri="{FF2B5EF4-FFF2-40B4-BE49-F238E27FC236}">
-                <a16:creationId xmlns:a16="http://schemas.microsoft.com/office/drawing/2014/main" id="{1C64A9BB-97DB-F80E-2412-C813FCB3EF42}"/>
-              </a:ext>
-            </a:extLst>
-          </p:cNvPr>
+          <p:cNvPr id="5" name="Footer Placeholder 4"/>
           <p:cNvSpPr>
             <a:spLocks noGrp="1"/>
           </p:cNvSpPr>
@@ -3391,8 +3028,8 @@
         </p:nvSpPr>
         <p:spPr>
           <a:xfrm>
-            <a:off x="4038600" y="6356350"/>
-            <a:ext cx="4114800" cy="365125"/>
+            <a:off x="2604582" y="6332809"/>
+            <a:ext cx="2653725" cy="363773"/>
           </a:xfrm>
           <a:prstGeom prst="rect">
             <a:avLst/>
@@ -3402,7 +3039,7 @@
           <a:bodyPr vert="horz" lIns="91440" tIns="45720" rIns="91440" bIns="45720" rtlCol="0" anchor="ctr"/>
           <a:lstStyle>
             <a:lvl1pPr algn="ctr">
-              <a:defRPr sz="1200">
+              <a:defRPr sz="1032">
                 <a:solidFill>
                   <a:schemeClr val="tx1">
                     <a:tint val="82000"/>
@@ -3418,13 +3055,7 @@
       </p:sp>
       <p:sp>
         <p:nvSpPr>
-          <p:cNvPr id="6" name="Foliennummernplatzhalter 5">
-            <a:extLst>
-              <a:ext uri="{FF2B5EF4-FFF2-40B4-BE49-F238E27FC236}">
-                <a16:creationId xmlns:a16="http://schemas.microsoft.com/office/drawing/2014/main" id="{9B033E02-80BF-7EE2-6F86-57ABF3E407C5}"/>
-              </a:ext>
-            </a:extLst>
-          </p:cNvPr>
+          <p:cNvPr id="6" name="Slide Number Placeholder 5"/>
           <p:cNvSpPr>
             <a:spLocks noGrp="1"/>
           </p:cNvSpPr>
@@ -3434,8 +3065,8 @@
         </p:nvSpPr>
         <p:spPr>
           <a:xfrm>
-            <a:off x="8610600" y="6356350"/>
-            <a:ext cx="2743200" cy="365125"/>
+            <a:off x="5553165" y="6332809"/>
+            <a:ext cx="1769150" cy="363773"/>
           </a:xfrm>
           <a:prstGeom prst="rect">
             <a:avLst/>
@@ -3445,7 +3076,7 @@
           <a:bodyPr vert="horz" lIns="91440" tIns="45720" rIns="91440" bIns="45720" rtlCol="0" anchor="ctr"/>
           <a:lstStyle>
             <a:lvl1pPr algn="r">
-              <a:defRPr sz="1200">
+              <a:defRPr sz="1032">
                 <a:solidFill>
                   <a:schemeClr val="tx1">
                     <a:tint val="82000"/>
@@ -3466,27 +3097,27 @@
     </p:spTree>
     <p:extLst>
       <p:ext uri="{BB962C8B-B14F-4D97-AF65-F5344CB8AC3E}">
-        <p14:creationId xmlns:p14="http://schemas.microsoft.com/office/powerpoint/2010/main" val="182396391"/>
+        <p14:creationId xmlns:p14="http://schemas.microsoft.com/office/powerpoint/2010/main" val="3583009345"/>
       </p:ext>
     </p:extLst>
   </p:cSld>
   <p:clrMap bg1="lt1" tx1="dk1" bg2="lt2" tx2="dk2" accent1="accent1" accent2="accent2" accent3="accent3" accent4="accent4" accent5="accent5" accent6="accent6" hlink="hlink" folHlink="folHlink"/>
   <p:sldLayoutIdLst>
-    <p:sldLayoutId id="2147483649" r:id="rId1"/>
-    <p:sldLayoutId id="2147483650" r:id="rId2"/>
-    <p:sldLayoutId id="2147483651" r:id="rId3"/>
-    <p:sldLayoutId id="2147483652" r:id="rId4"/>
-    <p:sldLayoutId id="2147483653" r:id="rId5"/>
-    <p:sldLayoutId id="2147483654" r:id="rId6"/>
-    <p:sldLayoutId id="2147483655" r:id="rId7"/>
-    <p:sldLayoutId id="2147483656" r:id="rId8"/>
-    <p:sldLayoutId id="2147483657" r:id="rId9"/>
-    <p:sldLayoutId id="2147483658" r:id="rId10"/>
-    <p:sldLayoutId id="2147483659" r:id="rId11"/>
+    <p:sldLayoutId id="2147483673" r:id="rId1"/>
+    <p:sldLayoutId id="2147483674" r:id="rId2"/>
+    <p:sldLayoutId id="2147483675" r:id="rId3"/>
+    <p:sldLayoutId id="2147483676" r:id="rId4"/>
+    <p:sldLayoutId id="2147483677" r:id="rId5"/>
+    <p:sldLayoutId id="2147483678" r:id="rId6"/>
+    <p:sldLayoutId id="2147483679" r:id="rId7"/>
+    <p:sldLayoutId id="2147483680" r:id="rId8"/>
+    <p:sldLayoutId id="2147483681" r:id="rId9"/>
+    <p:sldLayoutId id="2147483682" r:id="rId10"/>
+    <p:sldLayoutId id="2147483683" r:id="rId11"/>
   </p:sldLayoutIdLst>
   <p:txStyles>
     <p:titleStyle>
-      <a:lvl1pPr algn="l" defTabSz="914400" rtl="0" eaLnBrk="1" latinLnBrk="0" hangingPunct="1">
+      <a:lvl1pPr algn="l" defTabSz="786293" rtl="0" eaLnBrk="1" latinLnBrk="0" hangingPunct="1">
         <a:lnSpc>
           <a:spcPct val="90000"/>
         </a:lnSpc>
@@ -3494,7 +3125,7 @@
           <a:spcPct val="0"/>
         </a:spcBef>
         <a:buNone/>
-        <a:defRPr sz="4400" kern="1200">
+        <a:defRPr sz="3784" kern="1200">
           <a:solidFill>
             <a:schemeClr val="tx1"/>
           </a:solidFill>
@@ -3505,16 +3136,16 @@
       </a:lvl1pPr>
     </p:titleStyle>
     <p:bodyStyle>
-      <a:lvl1pPr marL="228600" indent="-228600" algn="l" defTabSz="914400" rtl="0" eaLnBrk="1" latinLnBrk="0" hangingPunct="1">
+      <a:lvl1pPr marL="196573" indent="-196573" algn="l" defTabSz="786293" rtl="0" eaLnBrk="1" latinLnBrk="0" hangingPunct="1">
         <a:lnSpc>
           <a:spcPct val="90000"/>
         </a:lnSpc>
         <a:spcBef>
-          <a:spcPts val="1000"/>
+          <a:spcPts val="860"/>
         </a:spcBef>
         <a:buFont typeface="Arial" panose="020B0604020202020204" pitchFamily="34" charset="0"/>
         <a:buChar char="•"/>
-        <a:defRPr sz="2800" kern="1200">
+        <a:defRPr sz="2408" kern="1200">
           <a:solidFill>
             <a:schemeClr val="tx1"/>
           </a:solidFill>
@@ -3523,16 +3154,16 @@
           <a:cs typeface="+mn-cs"/>
         </a:defRPr>
       </a:lvl1pPr>
-      <a:lvl2pPr marL="685800" indent="-228600" algn="l" defTabSz="914400" rtl="0" eaLnBrk="1" latinLnBrk="0" hangingPunct="1">
+      <a:lvl2pPr marL="589719" indent="-196573" algn="l" defTabSz="786293" rtl="0" eaLnBrk="1" latinLnBrk="0" hangingPunct="1">
         <a:lnSpc>
           <a:spcPct val="90000"/>
         </a:lnSpc>
         <a:spcBef>
-          <a:spcPts val="500"/>
+          <a:spcPts val="430"/>
         </a:spcBef>
         <a:buFont typeface="Arial" panose="020B0604020202020204" pitchFamily="34" charset="0"/>
         <a:buChar char="•"/>
-        <a:defRPr sz="2400" kern="1200">
+        <a:defRPr sz="2064" kern="1200">
           <a:solidFill>
             <a:schemeClr val="tx1"/>
           </a:solidFill>
@@ -3541,16 +3172,16 @@
           <a:cs typeface="+mn-cs"/>
         </a:defRPr>
       </a:lvl2pPr>
-      <a:lvl3pPr marL="1143000" indent="-228600" algn="l" defTabSz="914400" rtl="0" eaLnBrk="1" latinLnBrk="0" hangingPunct="1">
+      <a:lvl3pPr marL="982866" indent="-196573" algn="l" defTabSz="786293" rtl="0" eaLnBrk="1" latinLnBrk="0" hangingPunct="1">
         <a:lnSpc>
           <a:spcPct val="90000"/>
         </a:lnSpc>
         <a:spcBef>
-          <a:spcPts val="500"/>
+          <a:spcPts val="430"/>
         </a:spcBef>
         <a:buFont typeface="Arial" panose="020B0604020202020204" pitchFamily="34" charset="0"/>
         <a:buChar char="•"/>
-        <a:defRPr sz="2000" kern="1200">
+        <a:defRPr sz="1720" kern="1200">
           <a:solidFill>
             <a:schemeClr val="tx1"/>
           </a:solidFill>
@@ -3559,16 +3190,16 @@
           <a:cs typeface="+mn-cs"/>
         </a:defRPr>
       </a:lvl3pPr>
-      <a:lvl4pPr marL="1600200" indent="-228600" algn="l" defTabSz="914400" rtl="0" eaLnBrk="1" latinLnBrk="0" hangingPunct="1">
+      <a:lvl4pPr marL="1376012" indent="-196573" algn="l" defTabSz="786293" rtl="0" eaLnBrk="1" latinLnBrk="0" hangingPunct="1">
         <a:lnSpc>
           <a:spcPct val="90000"/>
         </a:lnSpc>
         <a:spcBef>
-          <a:spcPts val="500"/>
+          <a:spcPts val="430"/>
         </a:spcBef>
         <a:buFont typeface="Arial" panose="020B0604020202020204" pitchFamily="34" charset="0"/>
         <a:buChar char="•"/>
-        <a:defRPr sz="1800" kern="1200">
+        <a:defRPr sz="1548" kern="1200">
           <a:solidFill>
             <a:schemeClr val="tx1"/>
           </a:solidFill>
@@ -3577,16 +3208,16 @@
           <a:cs typeface="+mn-cs"/>
         </a:defRPr>
       </a:lvl4pPr>
-      <a:lvl5pPr marL="2057400" indent="-228600" algn="l" defTabSz="914400" rtl="0" eaLnBrk="1" latinLnBrk="0" hangingPunct="1">
+      <a:lvl5pPr marL="1769158" indent="-196573" algn="l" defTabSz="786293" rtl="0" eaLnBrk="1" latinLnBrk="0" hangingPunct="1">
         <a:lnSpc>
           <a:spcPct val="90000"/>
         </a:lnSpc>
         <a:spcBef>
-          <a:spcPts val="500"/>
+          <a:spcPts val="430"/>
         </a:spcBef>
         <a:buFont typeface="Arial" panose="020B0604020202020204" pitchFamily="34" charset="0"/>
         <a:buChar char="•"/>
-        <a:defRPr sz="1800" kern="1200">
+        <a:defRPr sz="1548" kern="1200">
           <a:solidFill>
             <a:schemeClr val="tx1"/>
           </a:solidFill>
@@ -3595,16 +3226,16 @@
           <a:cs typeface="+mn-cs"/>
         </a:defRPr>
       </a:lvl5pPr>
-      <a:lvl6pPr marL="2514600" indent="-228600" algn="l" defTabSz="914400" rtl="0" eaLnBrk="1" latinLnBrk="0" hangingPunct="1">
+      <a:lvl6pPr marL="2162305" indent="-196573" algn="l" defTabSz="786293" rtl="0" eaLnBrk="1" latinLnBrk="0" hangingPunct="1">
         <a:lnSpc>
           <a:spcPct val="90000"/>
         </a:lnSpc>
         <a:spcBef>
-          <a:spcPts val="500"/>
+          <a:spcPts val="430"/>
         </a:spcBef>
         <a:buFont typeface="Arial" panose="020B0604020202020204" pitchFamily="34" charset="0"/>
         <a:buChar char="•"/>
-        <a:defRPr sz="1800" kern="1200">
+        <a:defRPr sz="1548" kern="1200">
           <a:solidFill>
             <a:schemeClr val="tx1"/>
           </a:solidFill>
@@ -3613,16 +3244,16 @@
           <a:cs typeface="+mn-cs"/>
         </a:defRPr>
       </a:lvl6pPr>
-      <a:lvl7pPr marL="2971800" indent="-228600" algn="l" defTabSz="914400" rtl="0" eaLnBrk="1" latinLnBrk="0" hangingPunct="1">
+      <a:lvl7pPr marL="2555451" indent="-196573" algn="l" defTabSz="786293" rtl="0" eaLnBrk="1" latinLnBrk="0" hangingPunct="1">
         <a:lnSpc>
           <a:spcPct val="90000"/>
         </a:lnSpc>
         <a:spcBef>
-          <a:spcPts val="500"/>
+          <a:spcPts val="430"/>
         </a:spcBef>
         <a:buFont typeface="Arial" panose="020B0604020202020204" pitchFamily="34" charset="0"/>
         <a:buChar char="•"/>
-        <a:defRPr sz="1800" kern="1200">
+        <a:defRPr sz="1548" kern="1200">
           <a:solidFill>
             <a:schemeClr val="tx1"/>
           </a:solidFill>
@@ -3631,16 +3262,16 @@
           <a:cs typeface="+mn-cs"/>
         </a:defRPr>
       </a:lvl7pPr>
-      <a:lvl8pPr marL="3429000" indent="-228600" algn="l" defTabSz="914400" rtl="0" eaLnBrk="1" latinLnBrk="0" hangingPunct="1">
+      <a:lvl8pPr marL="2948597" indent="-196573" algn="l" defTabSz="786293" rtl="0" eaLnBrk="1" latinLnBrk="0" hangingPunct="1">
         <a:lnSpc>
           <a:spcPct val="90000"/>
         </a:lnSpc>
         <a:spcBef>
-          <a:spcPts val="500"/>
+          <a:spcPts val="430"/>
         </a:spcBef>
         <a:buFont typeface="Arial" panose="020B0604020202020204" pitchFamily="34" charset="0"/>
         <a:buChar char="•"/>
-        <a:defRPr sz="1800" kern="1200">
+        <a:defRPr sz="1548" kern="1200">
           <a:solidFill>
             <a:schemeClr val="tx1"/>
           </a:solidFill>
@@ -3649,16 +3280,16 @@
           <a:cs typeface="+mn-cs"/>
         </a:defRPr>
       </a:lvl8pPr>
-      <a:lvl9pPr marL="3886200" indent="-228600" algn="l" defTabSz="914400" rtl="0" eaLnBrk="1" latinLnBrk="0" hangingPunct="1">
+      <a:lvl9pPr marL="3341743" indent="-196573" algn="l" defTabSz="786293" rtl="0" eaLnBrk="1" latinLnBrk="0" hangingPunct="1">
         <a:lnSpc>
           <a:spcPct val="90000"/>
         </a:lnSpc>
         <a:spcBef>
-          <a:spcPts val="500"/>
+          <a:spcPts val="430"/>
         </a:spcBef>
         <a:buFont typeface="Arial" panose="020B0604020202020204" pitchFamily="34" charset="0"/>
         <a:buChar char="•"/>
-        <a:defRPr sz="1800" kern="1200">
+        <a:defRPr sz="1548" kern="1200">
           <a:solidFill>
             <a:schemeClr val="tx1"/>
           </a:solidFill>
@@ -3670,10 +3301,10 @@
     </p:bodyStyle>
     <p:otherStyle>
       <a:defPPr>
-        <a:defRPr lang="de-DE"/>
+        <a:defRPr lang="en-US"/>
       </a:defPPr>
-      <a:lvl1pPr marL="0" algn="l" defTabSz="914400" rtl="0" eaLnBrk="1" latinLnBrk="0" hangingPunct="1">
-        <a:defRPr sz="1800" kern="1200">
+      <a:lvl1pPr marL="0" algn="l" defTabSz="786293" rtl="0" eaLnBrk="1" latinLnBrk="0" hangingPunct="1">
+        <a:defRPr sz="1548" kern="1200">
           <a:solidFill>
             <a:schemeClr val="tx1"/>
           </a:solidFill>
@@ -3682,8 +3313,8 @@
           <a:cs typeface="+mn-cs"/>
         </a:defRPr>
       </a:lvl1pPr>
-      <a:lvl2pPr marL="457200" algn="l" defTabSz="914400" rtl="0" eaLnBrk="1" latinLnBrk="0" hangingPunct="1">
-        <a:defRPr sz="1800" kern="1200">
+      <a:lvl2pPr marL="393146" algn="l" defTabSz="786293" rtl="0" eaLnBrk="1" latinLnBrk="0" hangingPunct="1">
+        <a:defRPr sz="1548" kern="1200">
           <a:solidFill>
             <a:schemeClr val="tx1"/>
           </a:solidFill>
@@ -3692,8 +3323,8 @@
           <a:cs typeface="+mn-cs"/>
         </a:defRPr>
       </a:lvl2pPr>
-      <a:lvl3pPr marL="914400" algn="l" defTabSz="914400" rtl="0" eaLnBrk="1" latinLnBrk="0" hangingPunct="1">
-        <a:defRPr sz="1800" kern="1200">
+      <a:lvl3pPr marL="786293" algn="l" defTabSz="786293" rtl="0" eaLnBrk="1" latinLnBrk="0" hangingPunct="1">
+        <a:defRPr sz="1548" kern="1200">
           <a:solidFill>
             <a:schemeClr val="tx1"/>
           </a:solidFill>
@@ -3702,8 +3333,8 @@
           <a:cs typeface="+mn-cs"/>
         </a:defRPr>
       </a:lvl3pPr>
-      <a:lvl4pPr marL="1371600" algn="l" defTabSz="914400" rtl="0" eaLnBrk="1" latinLnBrk="0" hangingPunct="1">
-        <a:defRPr sz="1800" kern="1200">
+      <a:lvl4pPr marL="1179439" algn="l" defTabSz="786293" rtl="0" eaLnBrk="1" latinLnBrk="0" hangingPunct="1">
+        <a:defRPr sz="1548" kern="1200">
           <a:solidFill>
             <a:schemeClr val="tx1"/>
           </a:solidFill>
@@ -3712,8 +3343,8 @@
           <a:cs typeface="+mn-cs"/>
         </a:defRPr>
       </a:lvl4pPr>
-      <a:lvl5pPr marL="1828800" algn="l" defTabSz="914400" rtl="0" eaLnBrk="1" latinLnBrk="0" hangingPunct="1">
-        <a:defRPr sz="1800" kern="1200">
+      <a:lvl5pPr marL="1572585" algn="l" defTabSz="786293" rtl="0" eaLnBrk="1" latinLnBrk="0" hangingPunct="1">
+        <a:defRPr sz="1548" kern="1200">
           <a:solidFill>
             <a:schemeClr val="tx1"/>
           </a:solidFill>
@@ -3722,8 +3353,8 @@
           <a:cs typeface="+mn-cs"/>
         </a:defRPr>
       </a:lvl5pPr>
-      <a:lvl6pPr marL="2286000" algn="l" defTabSz="914400" rtl="0" eaLnBrk="1" latinLnBrk="0" hangingPunct="1">
-        <a:defRPr sz="1800" kern="1200">
+      <a:lvl6pPr marL="1965731" algn="l" defTabSz="786293" rtl="0" eaLnBrk="1" latinLnBrk="0" hangingPunct="1">
+        <a:defRPr sz="1548" kern="1200">
           <a:solidFill>
             <a:schemeClr val="tx1"/>
           </a:solidFill>
@@ -3732,8 +3363,8 @@
           <a:cs typeface="+mn-cs"/>
         </a:defRPr>
       </a:lvl6pPr>
-      <a:lvl7pPr marL="2743200" algn="l" defTabSz="914400" rtl="0" eaLnBrk="1" latinLnBrk="0" hangingPunct="1">
-        <a:defRPr sz="1800" kern="1200">
+      <a:lvl7pPr marL="2358878" algn="l" defTabSz="786293" rtl="0" eaLnBrk="1" latinLnBrk="0" hangingPunct="1">
+        <a:defRPr sz="1548" kern="1200">
           <a:solidFill>
             <a:schemeClr val="tx1"/>
           </a:solidFill>
@@ -3742,8 +3373,8 @@
           <a:cs typeface="+mn-cs"/>
         </a:defRPr>
       </a:lvl7pPr>
-      <a:lvl8pPr marL="3200400" algn="l" defTabSz="914400" rtl="0" eaLnBrk="1" latinLnBrk="0" hangingPunct="1">
-        <a:defRPr sz="1800" kern="1200">
+      <a:lvl8pPr marL="2752024" algn="l" defTabSz="786293" rtl="0" eaLnBrk="1" latinLnBrk="0" hangingPunct="1">
+        <a:defRPr sz="1548" kern="1200">
           <a:solidFill>
             <a:schemeClr val="tx1"/>
           </a:solidFill>
@@ -3752,8 +3383,8 @@
           <a:cs typeface="+mn-cs"/>
         </a:defRPr>
       </a:lvl8pPr>
-      <a:lvl9pPr marL="3657600" algn="l" defTabSz="914400" rtl="0" eaLnBrk="1" latinLnBrk="0" hangingPunct="1">
-        <a:defRPr sz="1800" kern="1200">
+      <a:lvl9pPr marL="3145170" algn="l" defTabSz="786293" rtl="0" eaLnBrk="1" latinLnBrk="0" hangingPunct="1">
+        <a:defRPr sz="1548" kern="1200">
           <a:solidFill>
             <a:schemeClr val="tx1"/>
           </a:solidFill>
@@ -3798,7 +3429,7 @@
         </p:nvSpPr>
         <p:spPr>
           <a:xfrm>
-            <a:off x="2218062" y="66675"/>
+            <a:off x="53508" y="53975"/>
             <a:ext cx="7755875" cy="6724650"/>
           </a:xfrm>
           <a:prstGeom prst="ellipse">
@@ -3852,7 +3483,7 @@
         </p:nvSpPr>
         <p:spPr>
           <a:xfrm>
-            <a:off x="2985571" y="2886419"/>
+            <a:off x="821015" y="2873721"/>
             <a:ext cx="6220854" cy="3597009"/>
           </a:xfrm>
           <a:prstGeom prst="ellipse">
@@ -3906,7 +3537,7 @@
         </p:nvSpPr>
         <p:spPr>
           <a:xfrm>
-            <a:off x="2790944" y="1360579"/>
+            <a:off x="626388" y="1347879"/>
             <a:ext cx="2232748" cy="1112708"/>
           </a:xfrm>
           <a:prstGeom prst="ellipse">
@@ -3964,7 +3595,7 @@
         </p:nvSpPr>
         <p:spPr>
           <a:xfrm>
-            <a:off x="2790944" y="1597528"/>
+            <a:off x="626388" y="1584830"/>
             <a:ext cx="2232748" cy="584775"/>
           </a:xfrm>
           <a:prstGeom prst="rect">
@@ -4008,7 +3639,7 @@
         </p:nvSpPr>
         <p:spPr>
           <a:xfrm>
-            <a:off x="4979624" y="247871"/>
+            <a:off x="2815068" y="235171"/>
             <a:ext cx="2232748" cy="1112708"/>
           </a:xfrm>
           <a:prstGeom prst="ellipse">
@@ -4066,7 +3697,7 @@
         </p:nvSpPr>
         <p:spPr>
           <a:xfrm>
-            <a:off x="7168304" y="1360579"/>
+            <a:off x="5003748" y="1347879"/>
             <a:ext cx="2232748" cy="1112708"/>
           </a:xfrm>
           <a:prstGeom prst="ellipse">
@@ -4124,7 +3755,7 @@
         </p:nvSpPr>
         <p:spPr>
           <a:xfrm>
-            <a:off x="7168304" y="1597527"/>
+            <a:off x="5003748" y="1584829"/>
             <a:ext cx="2232748" cy="584775"/>
           </a:xfrm>
           <a:prstGeom prst="rect">
@@ -4168,7 +3799,7 @@
         </p:nvSpPr>
         <p:spPr>
           <a:xfrm>
-            <a:off x="4979624" y="513799"/>
+            <a:off x="2815068" y="501101"/>
             <a:ext cx="2232748" cy="584775"/>
           </a:xfrm>
           <a:prstGeom prst="rect">
@@ -4212,7 +3843,7 @@
         </p:nvSpPr>
         <p:spPr>
           <a:xfrm>
-            <a:off x="4979624" y="3151788"/>
+            <a:off x="2815068" y="3139088"/>
             <a:ext cx="2232748" cy="1112708"/>
           </a:xfrm>
           <a:prstGeom prst="ellipse">
@@ -4270,7 +3901,7 @@
         </p:nvSpPr>
         <p:spPr>
           <a:xfrm>
-            <a:off x="4979624" y="3417716"/>
+            <a:off x="2815068" y="3405018"/>
             <a:ext cx="2232748" cy="584775"/>
           </a:xfrm>
           <a:prstGeom prst="rect">
@@ -4314,7 +3945,7 @@
         </p:nvSpPr>
         <p:spPr>
           <a:xfrm>
-            <a:off x="6608284" y="4529865"/>
+            <a:off x="4443728" y="4517165"/>
             <a:ext cx="2232748" cy="1112708"/>
           </a:xfrm>
           <a:prstGeom prst="ellipse">
@@ -4372,7 +4003,7 @@
         </p:nvSpPr>
         <p:spPr>
           <a:xfrm>
-            <a:off x="6608284" y="4795793"/>
+            <a:off x="4443728" y="4783095"/>
             <a:ext cx="2232748" cy="584775"/>
           </a:xfrm>
           <a:prstGeom prst="rect">
@@ -4420,7 +4051,7 @@
         </p:nvSpPr>
         <p:spPr>
           <a:xfrm>
-            <a:off x="3350969" y="4529865"/>
+            <a:off x="1186413" y="4517165"/>
             <a:ext cx="2232748" cy="1112708"/>
           </a:xfrm>
           <a:prstGeom prst="ellipse">
@@ -4478,7 +4109,7 @@
         </p:nvSpPr>
         <p:spPr>
           <a:xfrm>
-            <a:off x="3350969" y="4795793"/>
+            <a:off x="1186413" y="4783095"/>
             <a:ext cx="2232748" cy="584775"/>
           </a:xfrm>
           <a:prstGeom prst="rect">
@@ -4525,7 +4156,7 @@
         </p:nvCxnSpPr>
         <p:spPr>
           <a:xfrm>
-            <a:off x="6095998" y="1360579"/>
+            <a:off x="3931442" y="1347879"/>
             <a:ext cx="0" cy="1525840"/>
           </a:xfrm>
           <a:prstGeom prst="line">
@@ -4568,7 +4199,7 @@
         </p:nvCxnSpPr>
         <p:spPr>
           <a:xfrm rot="-2700000" flipH="1">
-            <a:off x="4102012" y="2339432"/>
+            <a:off x="1937456" y="2326732"/>
             <a:ext cx="10724" cy="939902"/>
           </a:xfrm>
           <a:prstGeom prst="line">
@@ -4611,7 +4242,7 @@
         </p:nvCxnSpPr>
         <p:spPr>
           <a:xfrm rot="2700000">
-            <a:off x="8029606" y="2339433"/>
+            <a:off x="5865050" y="2326733"/>
             <a:ext cx="10724" cy="939902"/>
           </a:xfrm>
           <a:prstGeom prst="line">

</xml_diff>